<commit_message>
Aggiorna presentazione: nuova copertina, pagine aspiratori dei dealer, M50 Cogeim
Co-Authored-By: Claude Sonnet 5.5 <noreply@anthropic.com>
Claude-Session: https://claude.ai/code/session_01SCg2HUqwJhu4yqN4qeMWhc
</commit_message>
<xml_diff>
--- a/DUPUY_Germania_Canali.pptx
+++ b/DUPUY_Germania_Canali.pptx
@@ -1338,44 +1338,8 @@
         <p:nvSpPr>
           <p:cNvPr id="3" name="Text 0"/>
           <p:cNvSpPr/>
-          <p:nvPr/>
-        </p:nvSpPr>
-        <p:spPr>
-          <a:xfrm>
-            <a:off x="457200" y="6492240"/>
-            <a:ext cx="7315200" cy="256032"/>
-          </a:xfrm>
-          <a:prstGeom prst="rect">
-            <a:avLst/>
-          </a:prstGeom>
-          <a:noFill/>
-          <a:ln/>
-        </p:spPr>
-        <p:txBody>
-          <a:bodyPr wrap="square" lIns="0" tIns="0" rIns="0" bIns="0" rtlCol="0" anchor="ctr"/>
-          <a:lstStyle/>
-          <a:p>
-            <a:pPr indent="0" marL="0">
-              <a:buNone/>
-            </a:pPr>
-            <a:r>
-              <a:rPr lang="en-US" sz="1000" dirty="0">
-                <a:solidFill>
-                  <a:schemeClr val="accent4"/>
-                </a:solidFill>
-              </a:rPr>
-              <a:t>DUPUY · Replicare in Germania i canali che funzionano</a:t>
-            </a:r>
-            <a:endParaRPr lang="en-US" sz="1000" dirty="0"/>
-          </a:p>
-        </p:txBody>
-      </p:sp>
-      <p:sp>
-        <p:nvSpPr>
-          <p:cNvPr id="4" name="Text 1"/>
-          <p:cNvSpPr/>
           <p:nvPr>
-            <p:ph idx="102" type="title" hasCustomPrompt="1"/>
+            <p:ph idx="101" type="title" hasCustomPrompt="1"/>
           </p:nvPr>
         </p:nvSpPr>
         <p:spPr>
@@ -1835,9 +1799,117 @@
           <a:chExt cx="0" cy="0"/>
         </a:xfrm>
       </p:grpSpPr>
+      <p:sp>
+        <p:nvSpPr>
+          <p:cNvPr id="2" name="Text 0"/>
+          <p:cNvSpPr txBox="1"/>
+          <p:nvPr/>
+        </p:nvSpPr>
+        <p:spPr>
+          <a:xfrm>
+            <a:off x="640080" y="2011680"/>
+            <a:ext cx="6400800" cy="274320"/>
+          </a:xfrm>
+          <a:prstGeom prst="rect">
+            <a:avLst/>
+          </a:prstGeom>
+          <a:noFill/>
+          <a:ln/>
+        </p:spPr>
+        <p:txBody>
+          <a:bodyPr wrap="square" lIns="0" tIns="0" rIns="0" bIns="0" rtlCol="0" anchor="ctr"/>
+          <a:lstStyle/>
+          <a:p>
+            <a:pPr indent="0" marL="0">
+              <a:buNone/>
+            </a:pPr>
+            <a:r>
+              <a:rPr lang="en-US" sz="1400" b="1" dirty="0">
+                <a:solidFill>
+                  <a:schemeClr val="accent1"/>
+                </a:solidFill>
+              </a:rPr>
+              <a:t>RETE DISTRIBUTIVA · GERMANIA</a:t>
+            </a:r>
+            <a:endParaRPr lang="en-US" sz="1400" dirty="0"/>
+          </a:p>
+        </p:txBody>
+      </p:sp>
+      <p:sp>
+        <p:nvSpPr>
+          <p:cNvPr id="3" name="Text 1"/>
+          <p:cNvSpPr txBox="1"/>
+          <p:nvPr/>
+        </p:nvSpPr>
+        <p:spPr>
+          <a:xfrm>
+            <a:off x="640080" y="2331720"/>
+            <a:ext cx="5852160" cy="1463040"/>
+          </a:xfrm>
+          <a:prstGeom prst="rect">
+            <a:avLst/>
+          </a:prstGeom>
+          <a:noFill/>
+          <a:ln/>
+        </p:spPr>
+        <p:txBody>
+          <a:bodyPr wrap="square" lIns="0" tIns="0" rIns="0" bIns="0" rtlCol="0" anchor="t"/>
+          <a:lstStyle/>
+          <a:p>
+            <a:pPr indent="0" marL="0">
+              <a:buNone/>
+            </a:pPr>
+            <a:r>
+              <a:rPr lang="en-US" sz="4400" b="1" dirty="0">
+                <a:solidFill>
+                  <a:schemeClr val="bg1"/>
+                </a:solidFill>
+              </a:rPr>
+              <a:t>Sviluppo canali distributivi</a:t>
+            </a:r>
+            <a:endParaRPr lang="en-US" sz="4400" dirty="0"/>
+          </a:p>
+        </p:txBody>
+      </p:sp>
+      <p:sp>
+        <p:nvSpPr>
+          <p:cNvPr id="4" name="Text 2"/>
+          <p:cNvSpPr txBox="1"/>
+          <p:nvPr/>
+        </p:nvSpPr>
+        <p:spPr>
+          <a:xfrm>
+            <a:off x="640080" y="4206240"/>
+            <a:ext cx="5852160" cy="822960"/>
+          </a:xfrm>
+          <a:prstGeom prst="rect">
+            <a:avLst/>
+          </a:prstGeom>
+          <a:noFill/>
+          <a:ln/>
+        </p:spPr>
+        <p:txBody>
+          <a:bodyPr wrap="square" lIns="0" tIns="0" rIns="0" bIns="0" rtlCol="0" anchor="t"/>
+          <a:lstStyle/>
+          <a:p>
+            <a:pPr indent="0" marL="0">
+              <a:buNone/>
+            </a:pPr>
+            <a:r>
+              <a:rPr lang="en-US" sz="1800" dirty="0">
+                <a:solidFill>
+                  <a:schemeClr val="bg1"/>
+                </a:solidFill>
+              </a:rPr>
+              <a:t>Best practice, risultati commerciali e metodo di mappatura dei distributori</a:t>
+            </a:r>
+            <a:endParaRPr lang="en-US" sz="1800" dirty="0"/>
+          </a:p>
+        </p:txBody>
+      </p:sp>
       <p:pic>
         <p:nvPicPr>
-          <p:cNvPr id="2" name="Image 0" descr="DUPUY">    </p:cNvPr>
+          <p:cNvPr id="5" name="Image 0" descr="DUPUY">    </p:cNvPr>
           <p:cNvPicPr>
             <a:picLocks noChangeAspect="1"/>
           </p:cNvPicPr>
@@ -1851,341 +1923,14 @@
         </p:blipFill>
         <p:spPr>
           <a:xfrm>
-            <a:off x="548640" y="502920"/>
-            <a:ext cx="2651760" cy="598406"/>
+            <a:off x="8321040" y="2834640"/>
+            <a:ext cx="3108960" cy="701579"/>
           </a:xfrm>
           <a:prstGeom prst="rect">
             <a:avLst/>
           </a:prstGeom>
         </p:spPr>
       </p:pic>
-      <p:sp>
-        <p:nvSpPr>
-          <p:cNvPr id="3" name="Text 0"/>
-          <p:cNvSpPr txBox="1"/>
-          <p:nvPr/>
-        </p:nvSpPr>
-        <p:spPr>
-          <a:xfrm>
-            <a:off x="548640" y="1920240"/>
-            <a:ext cx="5943600" cy="274320"/>
-          </a:xfrm>
-          <a:prstGeom prst="rect">
-            <a:avLst/>
-          </a:prstGeom>
-          <a:noFill/>
-          <a:ln/>
-        </p:spPr>
-        <p:txBody>
-          <a:bodyPr wrap="square" lIns="0" tIns="0" rIns="0" bIns="0" rtlCol="0" anchor="ctr"/>
-          <a:lstStyle/>
-          <a:p>
-            <a:pPr indent="0" marL="0">
-              <a:buNone/>
-            </a:pPr>
-            <a:r>
-              <a:rPr lang="en-US" sz="1400" b="1" dirty="0">
-                <a:solidFill>
-                  <a:schemeClr val="accent1"/>
-                </a:solidFill>
-              </a:rPr>
-              <a:t>RETE DISTRIBUTIVA · GERMANIA</a:t>
-            </a:r>
-            <a:endParaRPr lang="en-US" sz="1400" dirty="0"/>
-          </a:p>
-        </p:txBody>
-      </p:sp>
-      <p:sp>
-        <p:nvSpPr>
-          <p:cNvPr id="4" name="Text 1"/>
-          <p:cNvSpPr txBox="1"/>
-          <p:nvPr/>
-        </p:nvSpPr>
-        <p:spPr>
-          <a:xfrm>
-            <a:off x="548640" y="2240280"/>
-            <a:ext cx="6309360" cy="1920240"/>
-          </a:xfrm>
-          <a:prstGeom prst="rect">
-            <a:avLst/>
-          </a:prstGeom>
-          <a:noFill/>
-          <a:ln/>
-        </p:spPr>
-        <p:txBody>
-          <a:bodyPr wrap="square" lIns="0" tIns="0" rIns="0" bIns="0" rtlCol="0" anchor="t"/>
-          <a:lstStyle/>
-          <a:p>
-            <a:pPr indent="0" marL="0">
-              <a:buNone/>
-            </a:pPr>
-            <a:r>
-              <a:rPr lang="en-US" sz="4400" b="1" dirty="0">
-                <a:solidFill>
-                  <a:schemeClr val="bg1"/>
-                </a:solidFill>
-              </a:rPr>
-              <a:t>Replicare in Germania i canali che funzionano</a:t>
-            </a:r>
-            <a:endParaRPr lang="en-US" sz="4400" dirty="0"/>
-          </a:p>
-        </p:txBody>
-      </p:sp>
-      <p:sp>
-        <p:nvSpPr>
-          <p:cNvPr id="5" name="Text 2"/>
-          <p:cNvSpPr txBox="1"/>
-          <p:nvPr/>
-        </p:nvSpPr>
-        <p:spPr>
-          <a:xfrm>
-            <a:off x="548640" y="4343400"/>
-            <a:ext cx="5943600" cy="822960"/>
-          </a:xfrm>
-          <a:prstGeom prst="rect">
-            <a:avLst/>
-          </a:prstGeom>
-          <a:noFill/>
-          <a:ln/>
-        </p:spPr>
-        <p:txBody>
-          <a:bodyPr wrap="square" lIns="0" tIns="0" rIns="0" bIns="0" rtlCol="0" anchor="t"/>
-          <a:lstStyle/>
-          <a:p>
-            <a:pPr indent="0" marL="0">
-              <a:buNone/>
-            </a:pPr>
-            <a:r>
-              <a:rPr lang="en-US" sz="1800" dirty="0">
-                <a:solidFill>
-                  <a:schemeClr val="bg1"/>
-                </a:solidFill>
-              </a:rPr>
-              <a:t>Best practice, risultati commerciali e metodo di mappatura dei distributori</a:t>
-            </a:r>
-            <a:endParaRPr lang="en-US" sz="1800" dirty="0"/>
-          </a:p>
-        </p:txBody>
-      </p:sp>
-      <p:sp>
-        <p:nvSpPr>
-          <p:cNvPr id="6" name="Text 3"/>
-          <p:cNvSpPr txBox="1"/>
-          <p:nvPr/>
-        </p:nvSpPr>
-        <p:spPr>
-          <a:xfrm>
-            <a:off x="548640" y="5760720"/>
-            <a:ext cx="4572000" cy="365760"/>
-          </a:xfrm>
-          <a:prstGeom prst="rect">
-            <a:avLst/>
-          </a:prstGeom>
-          <a:noFill/>
-          <a:ln/>
-        </p:spPr>
-        <p:txBody>
-          <a:bodyPr wrap="square" lIns="0" tIns="0" rIns="0" bIns="0" rtlCol="0" anchor="ctr"/>
-          <a:lstStyle/>
-          <a:p>
-            <a:pPr indent="0" marL="0">
-              <a:buNone/>
-            </a:pPr>
-            <a:r>
-              <a:rPr lang="en-US" sz="1400" b="1" dirty="0">
-                <a:solidFill>
-                  <a:schemeClr val="accent4"/>
-                </a:solidFill>
-              </a:rPr>
-              <a:t>6 canali · 1 metodo</a:t>
-            </a:r>
-            <a:endParaRPr lang="en-US" sz="1400" dirty="0"/>
-          </a:p>
-        </p:txBody>
-      </p:sp>
-      <p:pic>
-        <p:nvPicPr>
-          <p:cNvPr id="7" name="Image 1" descr="Sabbiatura">    </p:cNvPr>
-          <p:cNvPicPr>
-            <a:picLocks noChangeAspect="1"/>
-          </p:cNvPicPr>
-          <p:nvPr/>
-        </p:nvPicPr>
-        <p:blipFill>
-          <a:blip r:embed="rId2"/>
-          <a:stretch>
-            <a:fillRect/>
-          </a:stretch>
-        </p:blipFill>
-        <p:spPr>
-          <a:xfrm>
-            <a:off x="7315200" y="548640"/>
-            <a:ext cx="2331720" cy="2331720"/>
-          </a:xfrm>
-          <a:prstGeom prst="rect">
-            <a:avLst/>
-          </a:prstGeom>
-        </p:spPr>
-      </p:pic>
-      <p:pic>
-        <p:nvPicPr>
-          <p:cNvPr id="8" name="Image 2" descr="Macchina CNC Okuma">    </p:cNvPr>
-          <p:cNvPicPr>
-            <a:picLocks noChangeAspect="1"/>
-          </p:cNvPicPr>
-          <p:nvPr/>
-        </p:nvPicPr>
-        <p:blipFill>
-          <a:blip r:embed="rId3"/>
-          <a:stretch>
-            <a:fillRect/>
-          </a:stretch>
-        </p:blipFill>
-        <p:spPr>
-          <a:xfrm>
-            <a:off x="9784080" y="548640"/>
-            <a:ext cx="2331720" cy="2331720"/>
-          </a:xfrm>
-          <a:prstGeom prst="rect">
-            <a:avLst/>
-          </a:prstGeom>
-        </p:spPr>
-      </p:pic>
-      <p:pic>
-        <p:nvPicPr>
-          <p:cNvPr id="9" name="Image 3" descr="Aspiratore industriale">    </p:cNvPr>
-          <p:cNvPicPr>
-            <a:picLocks noChangeAspect="1"/>
-          </p:cNvPicPr>
-          <p:nvPr/>
-        </p:nvPicPr>
-        <p:blipFill>
-          <a:blip r:embed="rId4"/>
-          <a:stretch>
-            <a:fillRect/>
-          </a:stretch>
-        </p:blipFill>
-        <p:spPr>
-          <a:xfrm>
-            <a:off x="7315200" y="3017520"/>
-            <a:ext cx="2331720" cy="2331720"/>
-          </a:xfrm>
-          <a:prstGeom prst="rect">
-            <a:avLst/>
-          </a:prstGeom>
-        </p:spPr>
-      </p:pic>
-      <p:sp>
-        <p:nvSpPr>
-          <p:cNvPr id="10" name="Shape 4"/>
-          <p:cNvSpPr/>
-          <p:nvPr/>
-        </p:nvSpPr>
-        <p:spPr>
-          <a:xfrm>
-            <a:off x="9784080" y="3017520"/>
-            <a:ext cx="2331720" cy="2331720"/>
-          </a:xfrm>
-          <a:prstGeom prst="rect">
-            <a:avLst/>
-          </a:prstGeom>
-          <a:solidFill>
-            <a:schemeClr val="accent1"/>
-          </a:solidFill>
-          <a:ln w="12700">
-            <a:solidFill>
-              <a:schemeClr val="accent1"/>
-            </a:solidFill>
-            <a:prstDash val="solid"/>
-          </a:ln>
-        </p:spPr>
-      </p:sp>
-      <p:sp>
-        <p:nvSpPr>
-          <p:cNvPr id="11" name="Text 5"/>
-          <p:cNvSpPr txBox="1"/>
-          <p:nvPr/>
-        </p:nvSpPr>
-        <p:spPr>
-          <a:xfrm>
-            <a:off x="9966960" y="3200400"/>
-            <a:ext cx="2011680" cy="1965960"/>
-          </a:xfrm>
-          <a:prstGeom prst="rect">
-            <a:avLst/>
-          </a:prstGeom>
-          <a:noFill/>
-          <a:ln/>
-        </p:spPr>
-        <p:txBody>
-          <a:bodyPr wrap="square" lIns="0" tIns="0" rIns="0" bIns="0" rtlCol="0" anchor="ctr"/>
-          <a:lstStyle/>
-          <a:p>
-            <a:pPr indent="0" marL="0">
-              <a:buNone/>
-            </a:pPr>
-            <a:r>
-              <a:rPr lang="en-US" sz="8000" b="1" dirty="0">
-                <a:solidFill>
-                  <a:schemeClr val="bg1"/>
-                </a:solidFill>
-              </a:rPr>
-              <a:t>6</a:t>
-            </a:r>
-            <a:endParaRPr lang="en-US" sz="8000" dirty="0"/>
-          </a:p>
-          <a:p>
-            <a:pPr indent="0" marL="0">
-              <a:buNone/>
-            </a:pPr>
-            <a:r>
-              <a:rPr lang="en-US" sz="1600" b="1" dirty="0">
-                <a:solidFill>
-                  <a:schemeClr val="bg1"/>
-                </a:solidFill>
-              </a:rPr>
-              <a:t>canali da replicare</a:t>
-            </a:r>
-            <a:endParaRPr lang="en-US" sz="8000" dirty="0"/>
-          </a:p>
-        </p:txBody>
-      </p:sp>
-      <p:sp>
-        <p:nvSpPr>
-          <p:cNvPr id="12" name="Text 6"/>
-          <p:cNvSpPr txBox="1"/>
-          <p:nvPr/>
-        </p:nvSpPr>
-        <p:spPr>
-          <a:xfrm>
-            <a:off x="7315200" y="5760720"/>
-            <a:ext cx="4800600" cy="365760"/>
-          </a:xfrm>
-          <a:prstGeom prst="rect">
-            <a:avLst/>
-          </a:prstGeom>
-          <a:noFill/>
-          <a:ln/>
-        </p:spPr>
-        <p:txBody>
-          <a:bodyPr wrap="square" lIns="0" tIns="0" rIns="0" bIns="0" rtlCol="0" anchor="ctr"/>
-          <a:lstStyle/>
-          <a:p>
-            <a:pPr algn="r" indent="0" marL="0">
-              <a:buNone/>
-            </a:pPr>
-            <a:r>
-              <a:rPr lang="en-US" sz="1200" dirty="0">
-                <a:solidFill>
-                  <a:schemeClr val="accent4"/>
-                </a:solidFill>
-              </a:rPr>
-              <a:t>Per Vincenzo e Matias</a:t>
-            </a:r>
-            <a:endParaRPr lang="en-US" sz="1200" dirty="0"/>
-          </a:p>
-        </p:txBody>
-      </p:sp>
     </p:spTree>
   </p:cSld>
   <p:clrMapOvr>
@@ -2249,10 +1994,10 @@
       </p:sp>
       <p:sp>
         <p:nvSpPr>
-          <p:cNvPr id="3" name="Text 1"/>
+          <p:cNvPr id="3" name="Text 0"/>
           <p:cNvSpPr/>
           <p:nvPr>
-            <p:ph idx="102" type="title" hasCustomPrompt="1"/>
+            <p:ph idx="101" type="title" hasCustomPrompt="1"/>
           </p:nvPr>
         </p:nvSpPr>
         <p:spPr>
@@ -2334,7 +2079,7 @@
         <p:spPr>
           <a:xfrm>
             <a:off x="475488" y="1389888"/>
-            <a:ext cx="3575304" cy="1188720"/>
+            <a:ext cx="3575304" cy="1143000"/>
           </a:xfrm>
           <a:prstGeom prst="rect">
             <a:avLst/>
@@ -2349,8 +2094,8 @@
         </p:nvSpPr>
         <p:spPr>
           <a:xfrm>
-            <a:off x="566928" y="1481328"/>
-            <a:ext cx="548640" cy="548640"/>
+            <a:off x="594360" y="2651760"/>
+            <a:ext cx="502920" cy="502920"/>
           </a:xfrm>
           <a:prstGeom prst="ellipse">
             <a:avLst/>
@@ -2358,9 +2103,9 @@
           <a:solidFill>
             <a:schemeClr val="accent1"/>
           </a:solidFill>
-          <a:ln w="25400">
+          <a:ln w="12700">
             <a:solidFill>
-              <a:schemeClr val="bg1"/>
+              <a:schemeClr val="accent1"/>
             </a:solidFill>
             <a:prstDash val="solid"/>
           </a:ln>
@@ -2374,8 +2119,8 @@
         </p:nvSpPr>
         <p:spPr>
           <a:xfrm>
-            <a:off x="566928" y="1481328"/>
-            <a:ext cx="548640" cy="548640"/>
+            <a:off x="594360" y="2651760"/>
+            <a:ext cx="502920" cy="502920"/>
           </a:xfrm>
           <a:prstGeom prst="rect">
             <a:avLst/>
@@ -2391,14 +2136,14 @@
               <a:buNone/>
             </a:pPr>
             <a:r>
-              <a:rPr lang="en-US" sz="2000" b="1" dirty="0">
+              <a:rPr lang="en-US" sz="1800" b="1" dirty="0">
                 <a:solidFill>
                   <a:schemeClr val="bg1"/>
                 </a:solidFill>
               </a:rPr>
               <a:t>1</a:t>
             </a:r>
-            <a:endParaRPr lang="en-US" sz="2000" dirty="0"/>
+            <a:endParaRPr lang="en-US" sz="1800" dirty="0"/>
           </a:p>
         </p:txBody>
       </p:sp>
@@ -2410,8 +2155,8 @@
         </p:nvSpPr>
         <p:spPr>
           <a:xfrm>
-            <a:off x="594360" y="2651760"/>
-            <a:ext cx="3337560" cy="310896"/>
+            <a:off x="1234440" y="2596896"/>
+            <a:ext cx="2743200" cy="329184"/>
           </a:xfrm>
           <a:prstGeom prst="rect">
             <a:avLst/>
@@ -2429,14 +2174,14 @@
               <a:buNone/>
             </a:pPr>
             <a:r>
-              <a:rPr lang="en-US" sz="1500" b="1" dirty="0">
+              <a:rPr lang="en-US" sz="1400" b="1" dirty="0">
                 <a:solidFill>
                   <a:schemeClr val="tx1"/>
                 </a:solidFill>
               </a:rPr>
               <a:t>Dealer macchine CNC</a:t>
             </a:r>
-            <a:endParaRPr lang="en-US" sz="1500" dirty="0"/>
+            <a:endParaRPr lang="en-US" sz="1400" dirty="0"/>
           </a:p>
         </p:txBody>
       </p:sp>
@@ -2448,8 +2193,8 @@
         </p:nvSpPr>
         <p:spPr>
           <a:xfrm>
-            <a:off x="594360" y="2944368"/>
-            <a:ext cx="3337560" cy="256032"/>
+            <a:off x="1234440" y="2926080"/>
+            <a:ext cx="2743200" cy="256032"/>
           </a:xfrm>
           <a:prstGeom prst="rect">
             <a:avLst/>
@@ -2525,7 +2270,7 @@
         <p:spPr>
           <a:xfrm>
             <a:off x="4306824" y="1389888"/>
-            <a:ext cx="3575304" cy="1188720"/>
+            <a:ext cx="3575304" cy="1143000"/>
           </a:xfrm>
           <a:prstGeom prst="rect">
             <a:avLst/>
@@ -2540,8 +2285,8 @@
         </p:nvSpPr>
         <p:spPr>
           <a:xfrm>
-            <a:off x="4398264" y="1481328"/>
-            <a:ext cx="548640" cy="548640"/>
+            <a:off x="4425696" y="2651760"/>
+            <a:ext cx="502920" cy="502920"/>
           </a:xfrm>
           <a:prstGeom prst="ellipse">
             <a:avLst/>
@@ -2549,9 +2294,9 @@
           <a:solidFill>
             <a:schemeClr val="accent1"/>
           </a:solidFill>
-          <a:ln w="25400">
+          <a:ln w="12700">
             <a:solidFill>
-              <a:schemeClr val="bg1"/>
+              <a:schemeClr val="accent1"/>
             </a:solidFill>
             <a:prstDash val="solid"/>
           </a:ln>
@@ -2565,8 +2310,8 @@
         </p:nvSpPr>
         <p:spPr>
           <a:xfrm>
-            <a:off x="4398264" y="1481328"/>
-            <a:ext cx="548640" cy="548640"/>
+            <a:off x="4425696" y="2651760"/>
+            <a:ext cx="502920" cy="502920"/>
           </a:xfrm>
           <a:prstGeom prst="rect">
             <a:avLst/>
@@ -2582,14 +2327,14 @@
               <a:buNone/>
             </a:pPr>
             <a:r>
-              <a:rPr lang="en-US" sz="2000" b="1" dirty="0">
+              <a:rPr lang="en-US" sz="1800" b="1" dirty="0">
                 <a:solidFill>
                   <a:schemeClr val="bg1"/>
                 </a:solidFill>
               </a:rPr>
               <a:t>2</a:t>
             </a:r>
-            <a:endParaRPr lang="en-US" sz="2000" dirty="0"/>
+            <a:endParaRPr lang="en-US" sz="1800" dirty="0"/>
           </a:p>
         </p:txBody>
       </p:sp>
@@ -2601,8 +2346,8 @@
         </p:nvSpPr>
         <p:spPr>
           <a:xfrm>
-            <a:off x="4425696" y="2651760"/>
-            <a:ext cx="3337560" cy="310896"/>
+            <a:off x="5065776" y="2596896"/>
+            <a:ext cx="2743200" cy="329184"/>
           </a:xfrm>
           <a:prstGeom prst="rect">
             <a:avLst/>
@@ -2620,14 +2365,14 @@
               <a:buNone/>
             </a:pPr>
             <a:r>
-              <a:rPr lang="en-US" sz="1500" b="1" dirty="0">
+              <a:rPr lang="en-US" sz="1400" b="1" dirty="0">
                 <a:solidFill>
                   <a:schemeClr val="tx1"/>
                 </a:solidFill>
               </a:rPr>
               <a:t>Dealer olio e lubrorefrigeranti</a:t>
             </a:r>
-            <a:endParaRPr lang="en-US" sz="1500" dirty="0"/>
+            <a:endParaRPr lang="en-US" sz="1400" dirty="0"/>
           </a:p>
         </p:txBody>
       </p:sp>
@@ -2639,8 +2384,8 @@
         </p:nvSpPr>
         <p:spPr>
           <a:xfrm>
-            <a:off x="4425696" y="2944368"/>
-            <a:ext cx="3337560" cy="256032"/>
+            <a:off x="5065776" y="2926080"/>
+            <a:ext cx="2743200" cy="256032"/>
           </a:xfrm>
           <a:prstGeom prst="rect">
             <a:avLst/>
@@ -2716,7 +2461,7 @@
         <p:spPr>
           <a:xfrm>
             <a:off x="8138160" y="1389888"/>
-            <a:ext cx="3575304" cy="1188720"/>
+            <a:ext cx="3575304" cy="1143000"/>
           </a:xfrm>
           <a:prstGeom prst="rect">
             <a:avLst/>
@@ -2731,8 +2476,8 @@
         </p:nvSpPr>
         <p:spPr>
           <a:xfrm>
-            <a:off x="8229600" y="1481328"/>
-            <a:ext cx="548640" cy="548640"/>
+            <a:off x="8257032" y="2651760"/>
+            <a:ext cx="502920" cy="502920"/>
           </a:xfrm>
           <a:prstGeom prst="ellipse">
             <a:avLst/>
@@ -2740,9 +2485,9 @@
           <a:solidFill>
             <a:schemeClr val="accent1"/>
           </a:solidFill>
-          <a:ln w="25400">
+          <a:ln w="12700">
             <a:solidFill>
-              <a:schemeClr val="bg1"/>
+              <a:schemeClr val="accent1"/>
             </a:solidFill>
             <a:prstDash val="solid"/>
           </a:ln>
@@ -2756,8 +2501,8 @@
         </p:nvSpPr>
         <p:spPr>
           <a:xfrm>
-            <a:off x="8229600" y="1481328"/>
-            <a:ext cx="548640" cy="548640"/>
+            <a:off x="8257032" y="2651760"/>
+            <a:ext cx="502920" cy="502920"/>
           </a:xfrm>
           <a:prstGeom prst="rect">
             <a:avLst/>
@@ -2773,14 +2518,14 @@
               <a:buNone/>
             </a:pPr>
             <a:r>
-              <a:rPr lang="en-US" sz="2000" b="1" dirty="0">
+              <a:rPr lang="en-US" sz="1800" b="1" dirty="0">
                 <a:solidFill>
                   <a:schemeClr val="bg1"/>
                 </a:solidFill>
               </a:rPr>
               <a:t>3</a:t>
             </a:r>
-            <a:endParaRPr lang="en-US" sz="2000" dirty="0"/>
+            <a:endParaRPr lang="en-US" sz="1800" dirty="0"/>
           </a:p>
         </p:txBody>
       </p:sp>
@@ -2792,8 +2537,8 @@
         </p:nvSpPr>
         <p:spPr>
           <a:xfrm>
-            <a:off x="8257032" y="2651760"/>
-            <a:ext cx="3337560" cy="310896"/>
+            <a:off x="8897112" y="2596896"/>
+            <a:ext cx="2743200" cy="329184"/>
           </a:xfrm>
           <a:prstGeom prst="rect">
             <a:avLst/>
@@ -2811,14 +2556,14 @@
               <a:buNone/>
             </a:pPr>
             <a:r>
-              <a:rPr lang="en-US" sz="1500" b="1" dirty="0">
+              <a:rPr lang="en-US" sz="1400" b="1" dirty="0">
                 <a:solidFill>
                   <a:schemeClr val="tx1"/>
                 </a:solidFill>
               </a:rPr>
               <a:t>Impianti di sabbiatura</a:t>
             </a:r>
-            <a:endParaRPr lang="en-US" sz="1500" dirty="0"/>
+            <a:endParaRPr lang="en-US" sz="1400" dirty="0"/>
           </a:p>
         </p:txBody>
       </p:sp>
@@ -2830,8 +2575,8 @@
         </p:nvSpPr>
         <p:spPr>
           <a:xfrm>
-            <a:off x="8257032" y="2944368"/>
-            <a:ext cx="3337560" cy="256032"/>
+            <a:off x="8897112" y="2926080"/>
+            <a:ext cx="2743200" cy="256032"/>
           </a:xfrm>
           <a:prstGeom prst="rect">
             <a:avLst/>
@@ -2907,7 +2652,7 @@
         <p:spPr>
           <a:xfrm>
             <a:off x="475488" y="3465576"/>
-            <a:ext cx="3575304" cy="1188720"/>
+            <a:ext cx="3575304" cy="1143000"/>
           </a:xfrm>
           <a:prstGeom prst="rect">
             <a:avLst/>
@@ -2922,8 +2667,8 @@
         </p:nvSpPr>
         <p:spPr>
           <a:xfrm>
-            <a:off x="566928" y="3557016"/>
-            <a:ext cx="548640" cy="548640"/>
+            <a:off x="594360" y="4727448"/>
+            <a:ext cx="502920" cy="502920"/>
           </a:xfrm>
           <a:prstGeom prst="ellipse">
             <a:avLst/>
@@ -2931,9 +2676,9 @@
           <a:solidFill>
             <a:schemeClr val="accent1"/>
           </a:solidFill>
-          <a:ln w="25400">
+          <a:ln w="12700">
             <a:solidFill>
-              <a:schemeClr val="bg1"/>
+              <a:schemeClr val="accent1"/>
             </a:solidFill>
             <a:prstDash val="solid"/>
           </a:ln>
@@ -2947,8 +2692,8 @@
         </p:nvSpPr>
         <p:spPr>
           <a:xfrm>
-            <a:off x="566928" y="3557016"/>
-            <a:ext cx="548640" cy="548640"/>
+            <a:off x="594360" y="4727448"/>
+            <a:ext cx="502920" cy="502920"/>
           </a:xfrm>
           <a:prstGeom prst="rect">
             <a:avLst/>
@@ -2964,14 +2709,14 @@
               <a:buNone/>
             </a:pPr>
             <a:r>
-              <a:rPr lang="en-US" sz="2000" b="1" dirty="0">
+              <a:rPr lang="en-US" sz="1800" b="1" dirty="0">
                 <a:solidFill>
                   <a:schemeClr val="bg1"/>
                 </a:solidFill>
               </a:rPr>
               <a:t>4</a:t>
             </a:r>
-            <a:endParaRPr lang="en-US" sz="2000" dirty="0"/>
+            <a:endParaRPr lang="en-US" sz="1800" dirty="0"/>
           </a:p>
         </p:txBody>
       </p:sp>
@@ -2983,8 +2728,8 @@
         </p:nvSpPr>
         <p:spPr>
           <a:xfrm>
-            <a:off x="594360" y="4727448"/>
-            <a:ext cx="3337560" cy="310896"/>
+            <a:off x="1234440" y="4672584"/>
+            <a:ext cx="2743200" cy="329184"/>
           </a:xfrm>
           <a:prstGeom prst="rect">
             <a:avLst/>
@@ -3002,14 +2747,14 @@
               <a:buNone/>
             </a:pPr>
             <a:r>
-              <a:rPr lang="en-US" sz="1500" b="1" dirty="0">
+              <a:rPr lang="en-US" sz="1400" b="1" dirty="0">
                 <a:solidFill>
                   <a:schemeClr val="tx1"/>
                 </a:solidFill>
               </a:rPr>
               <a:t>Utensilerie e gruppi d'acquisto</a:t>
             </a:r>
-            <a:endParaRPr lang="en-US" sz="1500" dirty="0"/>
+            <a:endParaRPr lang="en-US" sz="1400" dirty="0"/>
           </a:p>
         </p:txBody>
       </p:sp>
@@ -3021,8 +2766,8 @@
         </p:nvSpPr>
         <p:spPr>
           <a:xfrm>
-            <a:off x="594360" y="5020056"/>
-            <a:ext cx="3337560" cy="256032"/>
+            <a:off x="1234440" y="5001768"/>
+            <a:ext cx="2743200" cy="256032"/>
           </a:xfrm>
           <a:prstGeom prst="rect">
             <a:avLst/>
@@ -3098,7 +2843,7 @@
         <p:spPr>
           <a:xfrm>
             <a:off x="4306824" y="3465576"/>
-            <a:ext cx="3575304" cy="1188720"/>
+            <a:ext cx="3575304" cy="1143000"/>
           </a:xfrm>
           <a:prstGeom prst="rect">
             <a:avLst/>
@@ -3113,8 +2858,8 @@
         </p:nvSpPr>
         <p:spPr>
           <a:xfrm>
-            <a:off x="4398264" y="3557016"/>
-            <a:ext cx="548640" cy="548640"/>
+            <a:off x="4425696" y="4727448"/>
+            <a:ext cx="502920" cy="502920"/>
           </a:xfrm>
           <a:prstGeom prst="ellipse">
             <a:avLst/>
@@ -3122,9 +2867,9 @@
           <a:solidFill>
             <a:schemeClr val="accent1"/>
           </a:solidFill>
-          <a:ln w="25400">
+          <a:ln w="12700">
             <a:solidFill>
-              <a:schemeClr val="bg1"/>
+              <a:schemeClr val="accent1"/>
             </a:solidFill>
             <a:prstDash val="solid"/>
           </a:ln>
@@ -3138,8 +2883,8 @@
         </p:nvSpPr>
         <p:spPr>
           <a:xfrm>
-            <a:off x="4398264" y="3557016"/>
-            <a:ext cx="548640" cy="548640"/>
+            <a:off x="4425696" y="4727448"/>
+            <a:ext cx="502920" cy="502920"/>
           </a:xfrm>
           <a:prstGeom prst="rect">
             <a:avLst/>
@@ -3155,14 +2900,14 @@
               <a:buNone/>
             </a:pPr>
             <a:r>
-              <a:rPr lang="en-US" sz="2000" b="1" dirty="0">
+              <a:rPr lang="en-US" sz="1800" b="1" dirty="0">
                 <a:solidFill>
                   <a:schemeClr val="bg1"/>
                 </a:solidFill>
               </a:rPr>
               <a:t>5</a:t>
             </a:r>
-            <a:endParaRPr lang="en-US" sz="2000" dirty="0"/>
+            <a:endParaRPr lang="en-US" sz="1800" dirty="0"/>
           </a:p>
         </p:txBody>
       </p:sp>
@@ -3174,8 +2919,8 @@
         </p:nvSpPr>
         <p:spPr>
           <a:xfrm>
-            <a:off x="4425696" y="4727448"/>
-            <a:ext cx="3337560" cy="310896"/>
+            <a:off x="5065776" y="4672584"/>
+            <a:ext cx="2743200" cy="329184"/>
           </a:xfrm>
           <a:prstGeom prst="rect">
             <a:avLst/>
@@ -3193,14 +2938,14 @@
               <a:buNone/>
             </a:pPr>
             <a:r>
-              <a:rPr lang="en-US" sz="1500" b="1" dirty="0">
+              <a:rPr lang="en-US" sz="1400" b="1" dirty="0">
                 <a:solidFill>
                   <a:schemeClr val="tx1"/>
                 </a:solidFill>
               </a:rPr>
               <a:t>Impiantisti e integratori</a:t>
             </a:r>
-            <a:endParaRPr lang="en-US" sz="1500" dirty="0"/>
+            <a:endParaRPr lang="en-US" sz="1400" dirty="0"/>
           </a:p>
         </p:txBody>
       </p:sp>
@@ -3212,8 +2957,8 @@
         </p:nvSpPr>
         <p:spPr>
           <a:xfrm>
-            <a:off x="4425696" y="5020056"/>
-            <a:ext cx="3337560" cy="256032"/>
+            <a:off x="5065776" y="5001768"/>
+            <a:ext cx="2743200" cy="256032"/>
           </a:xfrm>
           <a:prstGeom prst="rect">
             <a:avLst/>
@@ -3289,7 +3034,7 @@
         <p:spPr>
           <a:xfrm>
             <a:off x="8138160" y="3465576"/>
-            <a:ext cx="3575304" cy="1188720"/>
+            <a:ext cx="3575304" cy="1143000"/>
           </a:xfrm>
           <a:prstGeom prst="rect">
             <a:avLst/>
@@ -3304,8 +3049,8 @@
         </p:nvSpPr>
         <p:spPr>
           <a:xfrm>
-            <a:off x="8229600" y="3557016"/>
-            <a:ext cx="548640" cy="548640"/>
+            <a:off x="8257032" y="4727448"/>
+            <a:ext cx="502920" cy="502920"/>
           </a:xfrm>
           <a:prstGeom prst="ellipse">
             <a:avLst/>
@@ -3313,9 +3058,9 @@
           <a:solidFill>
             <a:schemeClr val="accent1"/>
           </a:solidFill>
-          <a:ln w="25400">
+          <a:ln w="12700">
             <a:solidFill>
-              <a:schemeClr val="bg1"/>
+              <a:schemeClr val="accent1"/>
             </a:solidFill>
             <a:prstDash val="solid"/>
           </a:ln>
@@ -3329,8 +3074,8 @@
         </p:nvSpPr>
         <p:spPr>
           <a:xfrm>
-            <a:off x="8229600" y="3557016"/>
-            <a:ext cx="548640" cy="548640"/>
+            <a:off x="8257032" y="4727448"/>
+            <a:ext cx="502920" cy="502920"/>
           </a:xfrm>
           <a:prstGeom prst="rect">
             <a:avLst/>
@@ -3346,14 +3091,14 @@
               <a:buNone/>
             </a:pPr>
             <a:r>
-              <a:rPr lang="en-US" sz="2000" b="1" dirty="0">
+              <a:rPr lang="en-US" sz="1800" b="1" dirty="0">
                 <a:solidFill>
                   <a:schemeClr val="bg1"/>
                 </a:solidFill>
               </a:rPr>
               <a:t>6</a:t>
             </a:r>
-            <a:endParaRPr lang="en-US" sz="2000" dirty="0"/>
+            <a:endParaRPr lang="en-US" sz="1800" dirty="0"/>
           </a:p>
         </p:txBody>
       </p:sp>
@@ -3365,8 +3110,8 @@
         </p:nvSpPr>
         <p:spPr>
           <a:xfrm>
-            <a:off x="8257032" y="4727448"/>
-            <a:ext cx="3337560" cy="310896"/>
+            <a:off x="8897112" y="4672584"/>
+            <a:ext cx="2743200" cy="329184"/>
           </a:xfrm>
           <a:prstGeom prst="rect">
             <a:avLst/>
@@ -3384,14 +3129,14 @@
               <a:buNone/>
             </a:pPr>
             <a:r>
-              <a:rPr lang="en-US" sz="1500" b="1" dirty="0">
+              <a:rPr lang="en-US" sz="1400" b="1" dirty="0">
                 <a:solidFill>
                   <a:schemeClr val="tx1"/>
                 </a:solidFill>
               </a:rPr>
               <a:t>Dealer di marchi concorrenti</a:t>
             </a:r>
-            <a:endParaRPr lang="en-US" sz="1500" dirty="0"/>
+            <a:endParaRPr lang="en-US" sz="1400" dirty="0"/>
           </a:p>
         </p:txBody>
       </p:sp>
@@ -3403,8 +3148,8 @@
         </p:nvSpPr>
         <p:spPr>
           <a:xfrm>
-            <a:off x="8257032" y="5020056"/>
-            <a:ext cx="3337560" cy="256032"/>
+            <a:off x="8897112" y="5001768"/>
+            <a:ext cx="2743200" cy="256032"/>
           </a:xfrm>
           <a:prstGeom prst="rect">
             <a:avLst/>
@@ -3824,10 +3569,10 @@
       </p:sp>
       <p:sp>
         <p:nvSpPr>
-          <p:cNvPr id="3" name="Text 1"/>
+          <p:cNvPr id="3" name="Text 0"/>
           <p:cNvSpPr/>
           <p:nvPr>
-            <p:ph idx="102" type="title" hasCustomPrompt="1"/>
+            <p:ph idx="101" type="title" hasCustomPrompt="1"/>
           </p:nvPr>
         </p:nvSpPr>
         <p:spPr>
@@ -4290,7 +4035,7 @@
       </p:sp>
       <p:pic>
         <p:nvPicPr>
-          <p:cNvPr id="17" name="Image 0" descr="Sito MTC Flextek">    </p:cNvPr>
+          <p:cNvPr id="17" name="Image 0" descr="Sito MTC Flextek: filtrazione aria e liquidi">    </p:cNvPr>
           <p:cNvPicPr>
             <a:picLocks noChangeAspect="1"/>
           </p:cNvPicPr>
@@ -4714,10 +4459,10 @@
       </p:sp>
       <p:sp>
         <p:nvSpPr>
-          <p:cNvPr id="3" name="Text 1"/>
+          <p:cNvPr id="3" name="Text 0"/>
           <p:cNvSpPr/>
           <p:nvPr>
-            <p:ph idx="102" type="title" hasCustomPrompt="1"/>
+            <p:ph idx="101" type="title" hasCustomPrompt="1"/>
           </p:nvPr>
         </p:nvSpPr>
         <p:spPr>
@@ -5634,10 +5379,10 @@
       </p:sp>
       <p:sp>
         <p:nvSpPr>
-          <p:cNvPr id="3" name="Text 1"/>
+          <p:cNvPr id="3" name="Text 0"/>
           <p:cNvSpPr/>
           <p:nvPr>
-            <p:ph idx="102" type="title" hasCustomPrompt="1"/>
+            <p:ph idx="101" type="title" hasCustomPrompt="1"/>
           </p:nvPr>
         </p:nvSpPr>
         <p:spPr>
@@ -6061,7 +5806,63 @@
         <p:spPr>
           <a:xfrm>
             <a:off x="4937760" y="1371600"/>
-            <a:ext cx="6793992" cy="3108960"/>
+            <a:ext cx="4480560" cy="3108960"/>
+          </a:xfrm>
+          <a:prstGeom prst="rect">
+            <a:avLst/>
+          </a:prstGeom>
+          <a:solidFill>
+            <a:srgbClr val="FFFFFF"/>
+          </a:solidFill>
+          <a:ln w="12700">
+            <a:solidFill>
+              <a:schemeClr val="accent5"/>
+            </a:solidFill>
+            <a:prstDash val="solid"/>
+          </a:ln>
+          <a:effectLst>
+            <a:outerShdw sx="100000" sy="100000" kx="0" ky="0" algn="bl" rotWithShape="0" blurRad="101600" dist="25400" dir="5400000">
+              <a:srgbClr val="000000">
+                <a:alpha val="18000"/>
+              </a:srgbClr>
+            </a:outerShdw>
+          </a:effectLst>
+        </p:spPr>
+      </p:sp>
+      <p:pic>
+        <p:nvPicPr>
+          <p:cNvPr id="16" name="Image 0" descr="Sito Airblast: aspiratore abrasivi AbVac">    </p:cNvPr>
+          <p:cNvPicPr>
+            <a:picLocks noChangeAspect="1"/>
+          </p:cNvPicPr>
+          <p:nvPr/>
+        </p:nvPicPr>
+        <p:blipFill>
+          <a:blip r:embed="rId1"/>
+          <a:stretch>
+            <a:fillRect/>
+          </a:stretch>
+        </p:blipFill>
+        <p:spPr>
+          <a:xfrm>
+            <a:off x="4965192" y="1399032"/>
+            <a:ext cx="4425696" cy="3054096"/>
+          </a:xfrm>
+          <a:prstGeom prst="rect">
+            <a:avLst/>
+          </a:prstGeom>
+        </p:spPr>
+      </p:pic>
+      <p:sp>
+        <p:nvSpPr>
+          <p:cNvPr id="17" name="Shape 14"/>
+          <p:cNvSpPr/>
+          <p:nvPr/>
+        </p:nvSpPr>
+        <p:spPr>
+          <a:xfrm>
+            <a:off x="9555480" y="1371600"/>
+            <a:ext cx="2176272" cy="3108960"/>
           </a:xfrm>
           <a:prstGeom prst="rect">
             <a:avLst/>
@@ -6086,31 +5887,7 @@
       </p:sp>
       <p:pic>
         <p:nvPicPr>
-          <p:cNvPr id="16" name="Image 0" descr="Applicazioni sabbiatura">    </p:cNvPr>
-          <p:cNvPicPr>
-            <a:picLocks noChangeAspect="1"/>
-          </p:cNvPicPr>
-          <p:nvPr/>
-        </p:nvPicPr>
-        <p:blipFill>
-          <a:blip r:embed="rId1"/>
-          <a:stretch>
-            <a:fillRect/>
-          </a:stretch>
-        </p:blipFill>
-        <p:spPr>
-          <a:xfrm>
-            <a:off x="4965192" y="1399032"/>
-            <a:ext cx="2203704" cy="3054096"/>
-          </a:xfrm>
-          <a:prstGeom prst="rect">
-            <a:avLst/>
-          </a:prstGeom>
-        </p:spPr>
-      </p:pic>
-      <p:pic>
-        <p:nvPicPr>
-          <p:cNvPr id="17" name="Image 1" descr="Applicazioni sabbiatura">    </p:cNvPr>
+          <p:cNvPr id="18" name="Image 1" descr="M50 Cogeim">    </p:cNvPr>
           <p:cNvPicPr>
             <a:picLocks noChangeAspect="1"/>
           </p:cNvPicPr>
@@ -6124,41 +5901,78 @@
         </p:blipFill>
         <p:spPr>
           <a:xfrm>
-            <a:off x="7242048" y="1399032"/>
-            <a:ext cx="2203704" cy="3054096"/>
+            <a:off x="9774936" y="1417320"/>
+            <a:ext cx="1737360" cy="2606040"/>
           </a:xfrm>
           <a:prstGeom prst="rect">
             <a:avLst/>
           </a:prstGeom>
         </p:spPr>
       </p:pic>
-      <p:pic>
-        <p:nvPicPr>
-          <p:cNvPr id="18" name="Image 2" descr="Applicazioni sabbiatura">    </p:cNvPr>
-          <p:cNvPicPr>
-            <a:picLocks noChangeAspect="1"/>
-          </p:cNvPicPr>
-          <p:nvPr/>
-        </p:nvPicPr>
-        <p:blipFill>
-          <a:blip r:embed="rId3"/>
-          <a:stretch>
-            <a:fillRect/>
-          </a:stretch>
-        </p:blipFill>
-        <p:spPr>
-          <a:xfrm>
-            <a:off x="9518904" y="1399032"/>
-            <a:ext cx="2185416" cy="3054096"/>
-          </a:xfrm>
-          <a:prstGeom prst="rect">
-            <a:avLst/>
-          </a:prstGeom>
-        </p:spPr>
-      </p:pic>
-      <p:sp>
-        <p:nvSpPr>
-          <p:cNvPr id="19" name="Riga loghi"/>
+      <p:sp>
+        <p:nvSpPr>
+          <p:cNvPr id="19" name="Shape 15"/>
+          <p:cNvSpPr/>
+          <p:nvPr/>
+        </p:nvSpPr>
+        <p:spPr>
+          <a:xfrm>
+            <a:off x="9555480" y="4069080"/>
+            <a:ext cx="2176272" cy="411480"/>
+          </a:xfrm>
+          <a:prstGeom prst="rect">
+            <a:avLst/>
+          </a:prstGeom>
+          <a:solidFill>
+            <a:schemeClr val="tx1"/>
+          </a:solidFill>
+          <a:ln w="12700">
+            <a:solidFill>
+              <a:schemeClr val="tx1"/>
+            </a:solidFill>
+            <a:prstDash val="solid"/>
+          </a:ln>
+        </p:spPr>
+      </p:sp>
+      <p:sp>
+        <p:nvSpPr>
+          <p:cNvPr id="20" name="Text 16"/>
+          <p:cNvSpPr txBox="1"/>
+          <p:nvPr/>
+        </p:nvSpPr>
+        <p:spPr>
+          <a:xfrm>
+            <a:off x="9555480" y="4069080"/>
+            <a:ext cx="2176272" cy="411480"/>
+          </a:xfrm>
+          <a:prstGeom prst="rect">
+            <a:avLst/>
+          </a:prstGeom>
+          <a:noFill/>
+          <a:ln/>
+        </p:spPr>
+        <p:txBody>
+          <a:bodyPr wrap="square" lIns="0" tIns="0" rIns="0" bIns="0" rtlCol="0" anchor="ctr"/>
+          <a:lstStyle/>
+          <a:p>
+            <a:pPr algn="ctr" indent="0" marL="0">
+              <a:buNone/>
+            </a:pPr>
+            <a:r>
+              <a:rPr lang="en-US" sz="1400" b="1" dirty="0">
+                <a:solidFill>
+                  <a:schemeClr val="bg1"/>
+                </a:solidFill>
+              </a:rPr>
+              <a:t>M50 Cogeim</a:t>
+            </a:r>
+            <a:endParaRPr lang="en-US" sz="1400" dirty="0"/>
+          </a:p>
+        </p:txBody>
+      </p:sp>
+      <p:sp>
+        <p:nvSpPr>
+          <p:cNvPr id="21" name="Riga loghi"/>
           <p:cNvSpPr/>
           <p:nvPr/>
         </p:nvSpPr>
@@ -6185,14 +5999,14 @@
       </p:sp>
       <p:pic>
         <p:nvPicPr>
-          <p:cNvPr id="20" name="Image 3" descr="AIRBLAST">    </p:cNvPr>
+          <p:cNvPr id="22" name="Image 2" descr="AIRBLAST">    </p:cNvPr>
           <p:cNvPicPr>
             <a:picLocks noChangeAspect="1"/>
           </p:cNvPicPr>
           <p:nvPr/>
         </p:nvPicPr>
         <p:blipFill>
-          <a:blip r:embed="rId4"/>
+          <a:blip r:embed="rId3"/>
           <a:stretch>
             <a:fillRect/>
           </a:stretch>
@@ -6209,7 +6023,7 @@
       </p:pic>
       <p:sp>
         <p:nvSpPr>
-          <p:cNvPr id="21" name="Text 15"/>
+          <p:cNvPr id="23" name="Text 18"/>
           <p:cNvSpPr txBox="1"/>
           <p:nvPr/>
         </p:nvSpPr>
@@ -6259,7 +6073,7 @@
       </p:sp>
       <p:sp>
         <p:nvSpPr>
-          <p:cNvPr id="22" name="Banda Germania"/>
+          <p:cNvPr id="24" name="Banda Germania"/>
           <p:cNvSpPr/>
           <p:nvPr/>
         </p:nvSpPr>
@@ -6286,7 +6100,7 @@
       </p:sp>
       <p:sp>
         <p:nvSpPr>
-          <p:cNvPr id="23" name="Text 17"/>
+          <p:cNvPr id="25" name="Text 20"/>
           <p:cNvSpPr txBox="1"/>
           <p:nvPr/>
         </p:nvSpPr>
@@ -6322,7 +6136,7 @@
       </p:sp>
       <p:sp>
         <p:nvSpPr>
-          <p:cNvPr id="24" name="Text 18"/>
+          <p:cNvPr id="26" name="Text 21"/>
           <p:cNvSpPr txBox="1"/>
           <p:nvPr/>
         </p:nvSpPr>
@@ -6358,7 +6172,7 @@
       </p:sp>
       <p:sp>
         <p:nvSpPr>
-          <p:cNvPr id="25" name="Text 19"/>
+          <p:cNvPr id="27" name="Text 22"/>
           <p:cNvSpPr txBox="1"/>
           <p:nvPr/>
         </p:nvSpPr>
@@ -6500,10 +6314,10 @@
       </p:sp>
       <p:sp>
         <p:nvSpPr>
-          <p:cNvPr id="3" name="Text 1"/>
+          <p:cNvPr id="3" name="Text 0"/>
           <p:cNvSpPr/>
           <p:nvPr>
-            <p:ph idx="102" type="title" hasCustomPrompt="1"/>
+            <p:ph idx="101" type="title" hasCustomPrompt="1"/>
           </p:nvPr>
         </p:nvSpPr>
         <p:spPr>
@@ -7501,10 +7315,10 @@
       </p:sp>
       <p:sp>
         <p:nvSpPr>
-          <p:cNvPr id="3" name="Text 1"/>
+          <p:cNvPr id="3" name="Text 0"/>
           <p:cNvSpPr/>
           <p:nvPr>
-            <p:ph idx="102" type="title" hasCustomPrompt="1"/>
+            <p:ph idx="101" type="title" hasCustomPrompt="1"/>
           </p:nvPr>
         </p:nvSpPr>
         <p:spPr>
@@ -7964,7 +7778,7 @@
       </p:sp>
       <p:pic>
         <p:nvPicPr>
-          <p:cNvPr id="16" name="Image 0" descr="Sito Hardtest">    </p:cNvPr>
+          <p:cNvPr id="16" name="Image 0" descr="Sito Hardtest: Dupuy tra i marchi distribuiti">    </p:cNvPr>
           <p:cNvPicPr>
             <a:picLocks noChangeAspect="1"/>
           </p:cNvPicPr>
@@ -8364,10 +8178,10 @@
       </p:sp>
       <p:sp>
         <p:nvSpPr>
-          <p:cNvPr id="3" name="Text 1"/>
+          <p:cNvPr id="3" name="Text 0"/>
           <p:cNvSpPr/>
           <p:nvPr>
-            <p:ph idx="102" type="title" hasCustomPrompt="1"/>
+            <p:ph idx="101" type="title" hasCustomPrompt="1"/>
           </p:nvPr>
         </p:nvSpPr>
         <p:spPr>

</xml_diff>

<commit_message>
Aggiorna presentazione e aggiunge versioni EN e DE
Co-Authored-By: Claude Sonnet 5.5 <noreply@anthropic.com>
Claude-Session: https://claude.ai/code/session_01SCg2HUqwJhu4yqN4qeMWhc
</commit_message>
<xml_diff>
--- a/DUPUY_Germania_Canali.pptx
+++ b/DUPUY_Germania_Canali.pptx
@@ -6828,7 +6828,9 @@
       </p:sp>
       <p:pic>
         <p:nvPicPr>
-          <p:cNvPr id="18" name="Image 1" descr="Rubix">    </p:cNvPr>
+          <p:cNvPr id="18" name="Image 1" descr="Rubix">
+            <a:hlinkClick r:id="rId3" tooltip="Rubix"/>
+          </p:cNvPr>
           <p:cNvPicPr>
             <a:picLocks noChangeAspect="1"/>
           </p:cNvPicPr>
@@ -6842,8 +6844,8 @@
         </p:blipFill>
         <p:spPr>
           <a:xfrm>
-            <a:off x="5474208" y="4645152"/>
-            <a:ext cx="1121664" cy="365760"/>
+            <a:off x="5399532" y="4636008"/>
+            <a:ext cx="1261872" cy="411480"/>
           </a:xfrm>
           <a:prstGeom prst="rect">
             <a:avLst/>
@@ -6858,31 +6860,51 @@
         </p:nvSpPr>
         <p:spPr>
           <a:xfrm>
-            <a:off x="5010912" y="5029200"/>
-            <a:ext cx="2039112" cy="310896"/>
-          </a:xfrm>
-          <a:prstGeom prst="rect">
-            <a:avLst/>
-          </a:prstGeom>
-          <a:noFill/>
-          <a:ln/>
-        </p:spPr>
-        <p:txBody>
-          <a:bodyPr wrap="square" lIns="0" tIns="0" rIns="0" bIns="0" rtlCol="0" anchor="ctr"/>
+            <a:off x="4983480" y="5047488"/>
+            <a:ext cx="2093976" cy="292608"/>
+          </a:xfrm>
+          <a:prstGeom prst="rect">
+            <a:avLst/>
+          </a:prstGeom>
+          <a:noFill/>
+          <a:ln/>
+        </p:spPr>
+        <p:txBody>
+          <a:bodyPr wrap="square" lIns="0" tIns="0" rIns="0" bIns="0" rtlCol="0" anchor="ctr">
+            <a:normAutofit/>
+          </a:bodyPr>
           <a:lstStyle/>
           <a:p>
             <a:pPr algn="ctr" indent="0" marL="0">
               <a:buNone/>
             </a:pPr>
             <a:r>
-              <a:rPr lang="en-US" sz="1100" dirty="0">
+              <a:rPr lang="en-US" sz="1000" b="1" u="sng" dirty="0">
+                <a:solidFill>
+                  <a:schemeClr val="accent1"/>
+                </a:solidFill>
+                <a:hlinkClick r:id="rId4" invalidUrl="" action="" tgtFrame="" tooltip="" history="1" highlightClick="0" endSnd="0">
+                  <a:extLst>
+                    <a:ext uri="{A12FA001-AC4F-418D-AE19-62706E023703}">
+                      <ahyp:hlinkClr xmlns:ahyp="http://schemas.microsoft.com/office/drawing/2018/hyperlinkcolor" val="tx"/>
+                    </a:ext>
+                  </a:extLst>
+                </a:hlinkClick>
+              </a:rPr>
+              <a:t>rubix.com/it  ·  </a:t>
+            </a:r>
+            <a:pPr algn="ctr" indent="0" marL="0">
+              <a:buNone/>
+            </a:pPr>
+            <a:r>
+              <a:rPr lang="en-US" sz="1000" dirty="0">
                 <a:solidFill>
                   <a:schemeClr val="accent3"/>
                 </a:solidFill>
               </a:rPr>
-              <a:t>Italia · Francia · Spagna</a:t>
-            </a:r>
-            <a:endParaRPr lang="en-US" sz="1100" dirty="0"/>
+              <a:t>IT · FR · ES</a:t>
+            </a:r>
+            <a:endParaRPr lang="en-US" sz="1000" dirty="0"/>
           </a:p>
         </p:txBody>
       </p:sp>
@@ -6913,45 +6935,33 @@
           </a:ln>
         </p:spPr>
       </p:sp>
-      <p:sp>
-        <p:nvSpPr>
-          <p:cNvPr id="21" name="Text 17"/>
-          <p:cNvSpPr txBox="1"/>
-          <p:nvPr/>
-        </p:nvSpPr>
-        <p:spPr>
-          <a:xfrm>
-            <a:off x="7333488" y="4626864"/>
-            <a:ext cx="2002536" cy="365760"/>
-          </a:xfrm>
-          <a:prstGeom prst="rect">
-            <a:avLst/>
-          </a:prstGeom>
-          <a:noFill/>
-          <a:ln/>
-        </p:spPr>
-        <p:txBody>
-          <a:bodyPr wrap="square" lIns="0" tIns="0" rIns="0" bIns="0" rtlCol="0" anchor="ctr"/>
-          <a:lstStyle/>
-          <a:p>
-            <a:pPr algn="ctr" indent="0" marL="0">
-              <a:buNone/>
-            </a:pPr>
-            <a:r>
-              <a:rPr lang="en-US" sz="2000" b="1" dirty="0">
-                <a:solidFill>
-                  <a:schemeClr val="tx1"/>
-                </a:solidFill>
-              </a:rPr>
-              <a:t>CDU</a:t>
-            </a:r>
-            <a:endParaRPr lang="en-US" sz="2000" dirty="0"/>
-          </a:p>
-        </p:txBody>
-      </p:sp>
-      <p:sp>
-        <p:nvSpPr>
-          <p:cNvPr id="22" name="Text 18"/>
+      <p:pic>
+        <p:nvPicPr>
+          <p:cNvPr id="21" name="Image 2" descr="CDU">    </p:cNvPr>
+          <p:cNvPicPr>
+            <a:picLocks noChangeAspect="1"/>
+          </p:cNvPicPr>
+          <p:nvPr/>
+        </p:nvPicPr>
+        <p:blipFill>
+          <a:blip r:embed="rId5"/>
+          <a:stretch>
+            <a:fillRect/>
+          </a:stretch>
+        </p:blipFill>
+        <p:spPr>
+          <a:xfrm>
+            <a:off x="7795913" y="4636008"/>
+            <a:ext cx="1077686" cy="411480"/>
+          </a:xfrm>
+          <a:prstGeom prst="rect">
+            <a:avLst/>
+          </a:prstGeom>
+        </p:spPr>
+      </p:pic>
+      <p:sp>
+        <p:nvSpPr>
+          <p:cNvPr id="22" name="Text 17"/>
           <p:cNvSpPr txBox="1"/>
           <p:nvPr/>
         </p:nvSpPr>
@@ -6987,7 +6997,7 @@
       </p:sp>
       <p:sp>
         <p:nvSpPr>
-          <p:cNvPr id="23" name="Shape 19"/>
+          <p:cNvPr id="23" name="Shape 18"/>
           <p:cNvSpPr/>
           <p:nvPr/>
         </p:nvSpPr>
@@ -7014,22 +7024,22 @@
       </p:sp>
       <p:pic>
         <p:nvPicPr>
-          <p:cNvPr id="24" name="Image 2" descr="Cagelli">    </p:cNvPr>
+          <p:cNvPr id="24" name="Image 3" descr="Cagelli">    </p:cNvPr>
           <p:cNvPicPr>
             <a:picLocks noChangeAspect="1"/>
           </p:cNvPicPr>
           <p:nvPr/>
         </p:nvPicPr>
         <p:blipFill>
-          <a:blip r:embed="rId3"/>
+          <a:blip r:embed="rId6"/>
           <a:stretch>
             <a:fillRect/>
           </a:stretch>
         </p:blipFill>
         <p:spPr>
           <a:xfrm>
-            <a:off x="10094976" y="4645152"/>
-            <a:ext cx="1097280" cy="365760"/>
+            <a:off x="10021824" y="4636008"/>
+            <a:ext cx="1234440" cy="411480"/>
           </a:xfrm>
           <a:prstGeom prst="rect">
             <a:avLst/>
@@ -7038,7 +7048,7 @@
       </p:pic>
       <p:sp>
         <p:nvSpPr>
-          <p:cNvPr id="25" name="Text 20"/>
+          <p:cNvPr id="25" name="Text 19"/>
           <p:cNvSpPr txBox="1"/>
           <p:nvPr/>
         </p:nvSpPr>
@@ -7101,7 +7111,7 @@
       </p:sp>
       <p:sp>
         <p:nvSpPr>
-          <p:cNvPr id="27" name="Text 22"/>
+          <p:cNvPr id="27" name="Text 21"/>
           <p:cNvSpPr txBox="1"/>
           <p:nvPr/>
         </p:nvSpPr>
@@ -7137,7 +7147,7 @@
       </p:sp>
       <p:sp>
         <p:nvSpPr>
-          <p:cNvPr id="28" name="Text 23"/>
+          <p:cNvPr id="28" name="Text 22"/>
           <p:cNvSpPr txBox="1"/>
           <p:nvPr/>
         </p:nvSpPr>
@@ -7173,7 +7183,7 @@
       </p:sp>
       <p:sp>
         <p:nvSpPr>
-          <p:cNvPr id="29" name="Text 24"/>
+          <p:cNvPr id="29" name="Text 23"/>
           <p:cNvSpPr txBox="1"/>
           <p:nvPr/>
         </p:nvSpPr>
@@ -7836,7 +7846,7 @@
         <p:spPr>
           <a:xfrm>
             <a:off x="5120640" y="4590288"/>
-            <a:ext cx="3108960" cy="804672"/>
+            <a:ext cx="3200400" cy="804672"/>
           </a:xfrm>
           <a:prstGeom prst="rect">
             <a:avLst/>
@@ -7865,7 +7875,9 @@
       </p:sp>
       <p:pic>
         <p:nvPicPr>
-          <p:cNvPr id="19" name="Image 1" descr="hardtest">    </p:cNvPr>
+          <p:cNvPr id="19" name="Image 1" descr="Hardtest">
+            <a:hlinkClick r:id="rId3" tooltip="Hardtest"/>
+          </p:cNvPr>
           <p:cNvPicPr>
             <a:picLocks noChangeAspect="1"/>
           </p:cNvPicPr>
@@ -7879,65 +7891,62 @@
         </p:blipFill>
         <p:spPr>
           <a:xfrm>
-            <a:off x="8417052" y="4874895"/>
-            <a:ext cx="941832" cy="235458"/>
+            <a:off x="8732520" y="4626864"/>
+            <a:ext cx="1645920" cy="411480"/>
           </a:xfrm>
           <a:prstGeom prst="rect">
             <a:avLst/>
           </a:prstGeom>
         </p:spPr>
       </p:pic>
-      <p:pic>
-        <p:nvPicPr>
-          <p:cNvPr id="20" name="Image 2" descr="ruwac">    </p:cNvPr>
-          <p:cNvPicPr>
-            <a:picLocks noChangeAspect="1"/>
-          </p:cNvPicPr>
-          <p:nvPr/>
-        </p:nvPicPr>
-        <p:blipFill>
-          <a:blip r:embed="rId3"/>
-          <a:stretch>
-            <a:fillRect/>
-          </a:stretch>
-        </p:blipFill>
-        <p:spPr>
-          <a:xfrm>
-            <a:off x="9549384" y="4645152"/>
-            <a:ext cx="926592" cy="694944"/>
-          </a:xfrm>
-          <a:prstGeom prst="rect">
-            <a:avLst/>
-          </a:prstGeom>
-        </p:spPr>
-      </p:pic>
-      <p:pic>
-        <p:nvPicPr>
-          <p:cNvPr id="21" name="Image 3" descr="depureco">    </p:cNvPr>
-          <p:cNvPicPr>
-            <a:picLocks noChangeAspect="1"/>
-          </p:cNvPicPr>
-          <p:nvPr/>
-        </p:nvPicPr>
-        <p:blipFill>
-          <a:blip r:embed="rId4"/>
-          <a:stretch>
-            <a:fillRect/>
-          </a:stretch>
-        </p:blipFill>
-        <p:spPr>
-          <a:xfrm>
-            <a:off x="10674096" y="4645152"/>
-            <a:ext cx="926592" cy="694944"/>
-          </a:xfrm>
-          <a:prstGeom prst="rect">
-            <a:avLst/>
-          </a:prstGeom>
-        </p:spPr>
-      </p:pic>
-      <p:sp>
-        <p:nvSpPr>
-          <p:cNvPr id="22" name="Banda Germania"/>
+      <p:sp>
+        <p:nvSpPr>
+          <p:cNvPr id="20" name="Text 16">
+            <a:hlinkClick r:id="rId4" tooltip=""/>
+          </p:cNvPr>
+          <p:cNvSpPr txBox="1"/>
+          <p:nvPr/>
+        </p:nvSpPr>
+        <p:spPr>
+          <a:xfrm>
+            <a:off x="8412480" y="5047488"/>
+            <a:ext cx="2286000" cy="274320"/>
+          </a:xfrm>
+          <a:prstGeom prst="rect">
+            <a:avLst/>
+          </a:prstGeom>
+          <a:noFill/>
+          <a:ln/>
+        </p:spPr>
+        <p:txBody>
+          <a:bodyPr wrap="square" lIns="0" tIns="0" rIns="0" bIns="0" rtlCol="0" anchor="ctr"/>
+          <a:lstStyle/>
+          <a:p>
+            <a:pPr algn="ctr" indent="0" marL="0">
+              <a:buNone/>
+            </a:pPr>
+            <a:r>
+              <a:rPr lang="en-US" sz="1100" b="1" u="sng" dirty="0">
+                <a:solidFill>
+                  <a:schemeClr val="accent1"/>
+                </a:solidFill>
+                <a:hlinkClick r:id="rId4" invalidUrl="" action="" tgtFrame="" tooltip="" history="1" highlightClick="0" endSnd="0">
+                  <a:extLst>
+                    <a:ext uri="{A12FA001-AC4F-418D-AE19-62706E023703}">
+                      <ahyp:hlinkClr xmlns:ahyp="http://schemas.microsoft.com/office/drawing/2018/hyperlinkcolor" val="tx"/>
+                    </a:ext>
+                  </a:extLst>
+                </a:hlinkClick>
+              </a:rPr>
+              <a:t>Visit hardtest.hu</a:t>
+            </a:r>
+            <a:endParaRPr lang="en-US" sz="1100" dirty="0"/>
+          </a:p>
+        </p:txBody>
+      </p:sp>
+      <p:sp>
+        <p:nvSpPr>
+          <p:cNvPr id="21" name="Banda Germania"/>
           <p:cNvSpPr/>
           <p:nvPr/>
         </p:nvSpPr>
@@ -7964,7 +7973,7 @@
       </p:sp>
       <p:sp>
         <p:nvSpPr>
-          <p:cNvPr id="23" name="Text 17"/>
+          <p:cNvPr id="22" name="Text 18"/>
           <p:cNvSpPr txBox="1"/>
           <p:nvPr/>
         </p:nvSpPr>
@@ -8000,7 +8009,7 @@
       </p:sp>
       <p:sp>
         <p:nvSpPr>
-          <p:cNvPr id="24" name="Text 18"/>
+          <p:cNvPr id="23" name="Text 19"/>
           <p:cNvSpPr txBox="1"/>
           <p:nvPr/>
         </p:nvSpPr>
@@ -8036,7 +8045,7 @@
       </p:sp>
       <p:sp>
         <p:nvSpPr>
-          <p:cNvPr id="25" name="Text 19"/>
+          <p:cNvPr id="24" name="Text 20"/>
           <p:cNvSpPr txBox="1"/>
           <p:nvPr/>
         </p:nvSpPr>
@@ -8531,13 +8540,13 @@
         <p:spPr>
           <a:xfrm>
             <a:off x="4937760" y="1371600"/>
-            <a:ext cx="6793992" cy="3108960"/>
+            <a:ext cx="3291840" cy="3108960"/>
           </a:xfrm>
           <a:prstGeom prst="rect">
             <a:avLst/>
           </a:prstGeom>
           <a:solidFill>
-            <a:srgbClr val="FFFFFF"/>
+            <a:schemeClr val="bg1"/>
           </a:solidFill>
           <a:ln w="12700">
             <a:solidFill>
@@ -8556,7 +8565,7 @@
       </p:sp>
       <p:pic>
         <p:nvPicPr>
-          <p:cNvPr id="14" name="Image 0" descr="Cagelli rivende Absolent e Filtermist">    </p:cNvPr>
+          <p:cNvPr id="14" name="Image 0" descr="Cagelli → Filtermist · Absolent">    </p:cNvPr>
           <p:cNvPicPr>
             <a:picLocks noChangeAspect="1"/>
           </p:cNvPicPr>
@@ -8571,7 +8580,7 @@
         <p:spPr>
           <a:xfrm>
             <a:off x="4965192" y="1399032"/>
-            <a:ext cx="6739128" cy="3054096"/>
+            <a:ext cx="3236976" cy="2651760"/>
           </a:xfrm>
           <a:prstGeom prst="rect">
             <a:avLst/>
@@ -8581,6 +8590,184 @@
       <p:sp>
         <p:nvSpPr>
           <p:cNvPr id="15" name="Shape 12"/>
+          <p:cNvSpPr/>
+          <p:nvPr/>
+        </p:nvSpPr>
+        <p:spPr>
+          <a:xfrm>
+            <a:off x="4937760" y="4050792"/>
+            <a:ext cx="3291840" cy="429768"/>
+          </a:xfrm>
+          <a:prstGeom prst="rect">
+            <a:avLst/>
+          </a:prstGeom>
+          <a:solidFill>
+            <a:schemeClr val="tx1"/>
+          </a:solidFill>
+          <a:ln w="12700">
+            <a:solidFill>
+              <a:schemeClr val="tx1"/>
+            </a:solidFill>
+            <a:prstDash val="solid"/>
+          </a:ln>
+        </p:spPr>
+      </p:sp>
+      <p:sp>
+        <p:nvSpPr>
+          <p:cNvPr id="16" name="Text 13"/>
+          <p:cNvSpPr txBox="1"/>
+          <p:nvPr/>
+        </p:nvSpPr>
+        <p:spPr>
+          <a:xfrm>
+            <a:off x="4937760" y="4050792"/>
+            <a:ext cx="3291840" cy="429768"/>
+          </a:xfrm>
+          <a:prstGeom prst="rect">
+            <a:avLst/>
+          </a:prstGeom>
+          <a:noFill/>
+          <a:ln/>
+        </p:spPr>
+        <p:txBody>
+          <a:bodyPr wrap="square" lIns="0" tIns="0" rIns="0" bIns="0" rtlCol="0" anchor="ctr"/>
+          <a:lstStyle/>
+          <a:p>
+            <a:pPr algn="ctr" indent="0" marL="0">
+              <a:buNone/>
+            </a:pPr>
+            <a:r>
+              <a:rPr lang="en-US" sz="1200" b="1" dirty="0">
+                <a:solidFill>
+                  <a:schemeClr val="bg1"/>
+                </a:solidFill>
+              </a:rPr>
+              <a:t>Cagelli → Filtermist · Absolent</a:t>
+            </a:r>
+            <a:endParaRPr lang="en-US" sz="1200" dirty="0"/>
+          </a:p>
+        </p:txBody>
+      </p:sp>
+      <p:sp>
+        <p:nvSpPr>
+          <p:cNvPr id="17" name="Shape 14"/>
+          <p:cNvSpPr/>
+          <p:nvPr/>
+        </p:nvSpPr>
+        <p:spPr>
+          <a:xfrm>
+            <a:off x="8439912" y="1371600"/>
+            <a:ext cx="3291840" cy="3108960"/>
+          </a:xfrm>
+          <a:prstGeom prst="rect">
+            <a:avLst/>
+          </a:prstGeom>
+          <a:solidFill>
+            <a:schemeClr val="bg1"/>
+          </a:solidFill>
+          <a:ln w="12700">
+            <a:solidFill>
+              <a:schemeClr val="accent5"/>
+            </a:solidFill>
+            <a:prstDash val="solid"/>
+          </a:ln>
+          <a:effectLst>
+            <a:outerShdw sx="100000" sy="100000" kx="0" ky="0" algn="bl" rotWithShape="0" blurRad="101600" dist="25400" dir="5400000">
+              <a:srgbClr val="000000">
+                <a:alpha val="18000"/>
+              </a:srgbClr>
+            </a:outerShdw>
+          </a:effectLst>
+        </p:spPr>
+      </p:sp>
+      <p:pic>
+        <p:nvPicPr>
+          <p:cNvPr id="18" name="Image 1" descr="Hardtest → Depureco">    </p:cNvPr>
+          <p:cNvPicPr>
+            <a:picLocks noChangeAspect="1"/>
+          </p:cNvPicPr>
+          <p:nvPr/>
+        </p:nvPicPr>
+        <p:blipFill>
+          <a:blip r:embed="rId2"/>
+          <a:stretch>
+            <a:fillRect/>
+          </a:stretch>
+        </p:blipFill>
+        <p:spPr>
+          <a:xfrm>
+            <a:off x="8467344" y="1399032"/>
+            <a:ext cx="3236976" cy="2651760"/>
+          </a:xfrm>
+          <a:prstGeom prst="rect">
+            <a:avLst/>
+          </a:prstGeom>
+        </p:spPr>
+      </p:pic>
+      <p:sp>
+        <p:nvSpPr>
+          <p:cNvPr id="19" name="Shape 15"/>
+          <p:cNvSpPr/>
+          <p:nvPr/>
+        </p:nvSpPr>
+        <p:spPr>
+          <a:xfrm>
+            <a:off x="8439912" y="4050792"/>
+            <a:ext cx="3291840" cy="429768"/>
+          </a:xfrm>
+          <a:prstGeom prst="rect">
+            <a:avLst/>
+          </a:prstGeom>
+          <a:solidFill>
+            <a:schemeClr val="tx1"/>
+          </a:solidFill>
+          <a:ln w="12700">
+            <a:solidFill>
+              <a:schemeClr val="tx1"/>
+            </a:solidFill>
+            <a:prstDash val="solid"/>
+          </a:ln>
+        </p:spPr>
+      </p:sp>
+      <p:sp>
+        <p:nvSpPr>
+          <p:cNvPr id="20" name="Text 16"/>
+          <p:cNvSpPr txBox="1"/>
+          <p:nvPr/>
+        </p:nvSpPr>
+        <p:spPr>
+          <a:xfrm>
+            <a:off x="8439912" y="4050792"/>
+            <a:ext cx="3291840" cy="429768"/>
+          </a:xfrm>
+          <a:prstGeom prst="rect">
+            <a:avLst/>
+          </a:prstGeom>
+          <a:noFill/>
+          <a:ln/>
+        </p:spPr>
+        <p:txBody>
+          <a:bodyPr wrap="square" lIns="0" tIns="0" rIns="0" bIns="0" rtlCol="0" anchor="ctr"/>
+          <a:lstStyle/>
+          <a:p>
+            <a:pPr algn="ctr" indent="0" marL="0">
+              <a:buNone/>
+            </a:pPr>
+            <a:r>
+              <a:rPr lang="en-US" sz="1200" b="1" dirty="0">
+                <a:solidFill>
+                  <a:schemeClr val="bg1"/>
+                </a:solidFill>
+              </a:rPr>
+              <a:t>Hardtest → Depureco</a:t>
+            </a:r>
+            <a:endParaRPr lang="en-US" sz="1200" dirty="0"/>
+          </a:p>
+        </p:txBody>
+      </p:sp>
+      <p:sp>
+        <p:nvSpPr>
+          <p:cNvPr id="21" name="Shape 17"/>
           <p:cNvSpPr/>
           <p:nvPr/>
         </p:nvSpPr>
@@ -8607,7 +8794,7 @@
       </p:sp>
       <p:sp>
         <p:nvSpPr>
-          <p:cNvPr id="16" name="Text 13"/>
+          <p:cNvPr id="22" name="Text 18"/>
           <p:cNvSpPr txBox="1"/>
           <p:nvPr/>
         </p:nvSpPr>
@@ -8659,7 +8846,7 @@
       </p:sp>
       <p:sp>
         <p:nvSpPr>
-          <p:cNvPr id="17" name="Shape 14"/>
+          <p:cNvPr id="23" name="Shape 19"/>
           <p:cNvSpPr/>
           <p:nvPr/>
         </p:nvSpPr>
@@ -8686,7 +8873,7 @@
       </p:sp>
       <p:sp>
         <p:nvSpPr>
-          <p:cNvPr id="18" name="Text 15"/>
+          <p:cNvPr id="24" name="Text 20"/>
           <p:cNvSpPr txBox="1"/>
           <p:nvPr/>
         </p:nvSpPr>
@@ -8738,7 +8925,7 @@
       </p:sp>
       <p:sp>
         <p:nvSpPr>
-          <p:cNvPr id="19" name="Shape 16"/>
+          <p:cNvPr id="25" name="Shape 21"/>
           <p:cNvSpPr/>
           <p:nvPr/>
         </p:nvSpPr>
@@ -8765,7 +8952,7 @@
       </p:sp>
       <p:sp>
         <p:nvSpPr>
-          <p:cNvPr id="20" name="Text 17"/>
+          <p:cNvPr id="26" name="Text 22"/>
           <p:cNvSpPr txBox="1"/>
           <p:nvPr/>
         </p:nvSpPr>
@@ -8817,7 +9004,7 @@
       </p:sp>
       <p:sp>
         <p:nvSpPr>
-          <p:cNvPr id="21" name="Banda Germania"/>
+          <p:cNvPr id="27" name="Banda Germania"/>
           <p:cNvSpPr/>
           <p:nvPr/>
         </p:nvSpPr>
@@ -8844,7 +9031,7 @@
       </p:sp>
       <p:sp>
         <p:nvSpPr>
-          <p:cNvPr id="22" name="Text 19"/>
+          <p:cNvPr id="28" name="Text 24"/>
           <p:cNvSpPr txBox="1"/>
           <p:nvPr/>
         </p:nvSpPr>
@@ -8880,7 +9067,7 @@
       </p:sp>
       <p:sp>
         <p:nvSpPr>
-          <p:cNvPr id="23" name="Text 20"/>
+          <p:cNvPr id="29" name="Text 25"/>
           <p:cNvSpPr txBox="1"/>
           <p:nvPr/>
         </p:nvSpPr>
@@ -8916,7 +9103,7 @@
       </p:sp>
       <p:sp>
         <p:nvSpPr>
-          <p:cNvPr id="24" name="Text 21"/>
+          <p:cNvPr id="30" name="Text 26"/>
           <p:cNvSpPr txBox="1"/>
           <p:nvPr/>
         </p:nvSpPr>
@@ -9036,8 +9223,8 @@
         </p:blipFill>
         <p:spPr>
           <a:xfrm>
-            <a:off x="548640" y="502920"/>
-            <a:ext cx="2651760" cy="598406"/>
+            <a:off x="548640" y="457200"/>
+            <a:ext cx="2377440" cy="536502"/>
           </a:xfrm>
           <a:prstGeom prst="rect">
             <a:avLst/>
@@ -9052,8 +9239,8 @@
         </p:nvSpPr>
         <p:spPr>
           <a:xfrm>
-            <a:off x="548640" y="1554480"/>
-            <a:ext cx="10972800" cy="822960"/>
+            <a:off x="548640" y="1325880"/>
+            <a:ext cx="11064240" cy="1463040"/>
           </a:xfrm>
           <a:prstGeom prst="rect">
             <a:avLst/>
@@ -9069,67 +9256,45 @@
               <a:buNone/>
             </a:pPr>
             <a:r>
-              <a:rPr lang="en-US" sz="3600" b="1" dirty="0">
+              <a:rPr lang="en-US" sz="3000" b="1" dirty="0">
                 <a:solidFill>
                   <a:schemeClr val="bg1"/>
                 </a:solidFill>
               </a:rPr>
               <a:t>Non inventiamo nuovi canali.</a:t>
             </a:r>
-            <a:endParaRPr lang="en-US" sz="3600" dirty="0"/>
-          </a:p>
-        </p:txBody>
-      </p:sp>
-      <p:sp>
-        <p:nvSpPr>
-          <p:cNvPr id="4" name="Text 1"/>
-          <p:cNvSpPr txBox="1"/>
-          <p:nvPr/>
-        </p:nvSpPr>
-        <p:spPr>
-          <a:xfrm>
-            <a:off x="548640" y="2377440"/>
-            <a:ext cx="10972800" cy="822960"/>
-          </a:xfrm>
-          <a:prstGeom prst="rect">
-            <a:avLst/>
-          </a:prstGeom>
-          <a:noFill/>
-          <a:ln/>
-        </p:spPr>
-        <p:txBody>
-          <a:bodyPr wrap="square" lIns="0" tIns="0" rIns="0" bIns="0" rtlCol="0" anchor="ctr"/>
-          <a:lstStyle/>
-          <a:p>
-            <a:pPr indent="0" marL="0">
-              <a:buNone/>
-            </a:pPr>
-            <a:r>
-              <a:rPr lang="en-US" sz="3600" b="1" dirty="0">
+            <a:endParaRPr lang="en-US" sz="3000" dirty="0"/>
+          </a:p>
+          <a:p>
+            <a:pPr indent="0" marL="0">
+              <a:buNone/>
+            </a:pPr>
+            <a:r>
+              <a:rPr lang="en-US" sz="3000" b="1" dirty="0">
                 <a:solidFill>
                   <a:schemeClr val="accent1"/>
                 </a:solidFill>
               </a:rPr>
               <a:t>Replichiamo in Germania ciò che funziona già.</a:t>
             </a:r>
-            <a:endParaRPr lang="en-US" sz="3600" dirty="0"/>
-          </a:p>
-        </p:txBody>
-      </p:sp>
-      <p:sp>
-        <p:nvSpPr>
-          <p:cNvPr id="5" name="Shape 2"/>
+            <a:endParaRPr lang="en-US" sz="3000" dirty="0"/>
+          </a:p>
+        </p:txBody>
+      </p:sp>
+      <p:sp>
+        <p:nvSpPr>
+          <p:cNvPr id="4" name="Shape 1"/>
           <p:cNvSpPr/>
           <p:nvPr/>
         </p:nvSpPr>
         <p:spPr>
           <a:xfrm>
-            <a:off x="548640" y="3611880"/>
-            <a:ext cx="3520440" cy="1463040"/>
+            <a:off x="548640" y="3017520"/>
+            <a:ext cx="3520440" cy="2788920"/>
           </a:xfrm>
           <a:prstGeom prst="roundRect">
             <a:avLst>
-              <a:gd name="adj" fmla="val 7500"/>
+              <a:gd name="adj" fmla="val 3934"/>
             </a:avLst>
           </a:prstGeom>
           <a:solidFill>
@@ -9145,14 +9310,50 @@
       </p:sp>
       <p:sp>
         <p:nvSpPr>
+          <p:cNvPr id="5" name="Text 2"/>
+          <p:cNvSpPr txBox="1"/>
+          <p:nvPr/>
+        </p:nvSpPr>
+        <p:spPr>
+          <a:xfrm>
+            <a:off x="731520" y="3108960"/>
+            <a:ext cx="548640" cy="731520"/>
+          </a:xfrm>
+          <a:prstGeom prst="rect">
+            <a:avLst/>
+          </a:prstGeom>
+          <a:noFill/>
+          <a:ln/>
+        </p:spPr>
+        <p:txBody>
+          <a:bodyPr wrap="square" lIns="0" tIns="0" rIns="0" bIns="0" rtlCol="0" anchor="ctr"/>
+          <a:lstStyle/>
+          <a:p>
+            <a:pPr indent="0" marL="0">
+              <a:buNone/>
+            </a:pPr>
+            <a:r>
+              <a:rPr lang="en-US" sz="4400" b="1" dirty="0">
+                <a:solidFill>
+                  <a:schemeClr val="accent1"/>
+                </a:solidFill>
+              </a:rPr>
+              <a:t>1</a:t>
+            </a:r>
+            <a:endParaRPr lang="en-US" sz="4400" dirty="0"/>
+          </a:p>
+        </p:txBody>
+      </p:sp>
+      <p:sp>
+        <p:nvSpPr>
           <p:cNvPr id="6" name="Text 3"/>
           <p:cNvSpPr txBox="1"/>
           <p:nvPr/>
         </p:nvSpPr>
         <p:spPr>
           <a:xfrm>
-            <a:off x="777240" y="3703320"/>
-            <a:ext cx="731520" cy="1280160"/>
+            <a:off x="1325880" y="3108960"/>
+            <a:ext cx="2606040" cy="731520"/>
           </a:xfrm>
           <a:prstGeom prst="rect">
             <a:avLst/>
@@ -9168,14 +9369,14 @@
               <a:buNone/>
             </a:pPr>
             <a:r>
-              <a:rPr lang="en-US" sz="6000" b="1" dirty="0">
-                <a:solidFill>
-                  <a:schemeClr val="accent1"/>
-                </a:solidFill>
-              </a:rPr>
-              <a:t>1</a:t>
-            </a:r>
-            <a:endParaRPr lang="en-US" sz="6000" dirty="0"/>
+              <a:rPr lang="en-US" sz="1700" b="1" dirty="0">
+                <a:solidFill>
+                  <a:schemeClr val="bg1"/>
+                </a:solidFill>
+              </a:rPr>
+              <a:t>Chi è il distributore ideale</a:t>
+            </a:r>
+            <a:endParaRPr lang="en-US" sz="1700" dirty="0"/>
           </a:p>
         </p:txBody>
       </p:sp>
@@ -9187,62 +9388,111 @@
         </p:nvSpPr>
         <p:spPr>
           <a:xfrm>
-            <a:off x="1554480" y="3703320"/>
-            <a:ext cx="2377440" cy="1280160"/>
-          </a:xfrm>
-          <a:prstGeom prst="rect">
-            <a:avLst/>
-          </a:prstGeom>
-          <a:noFill/>
-          <a:ln/>
-        </p:spPr>
-        <p:txBody>
-          <a:bodyPr wrap="square" lIns="0" tIns="0" rIns="0" bIns="0" rtlCol="0" anchor="ctr"/>
-          <a:lstStyle/>
-          <a:p>
-            <a:pPr indent="0" marL="0">
-              <a:buNone/>
-            </a:pPr>
-            <a:r>
-              <a:rPr lang="en-US" sz="1800" b="1" dirty="0">
+            <a:off x="777240" y="3886200"/>
+            <a:ext cx="3063240" cy="640080"/>
+          </a:xfrm>
+          <a:prstGeom prst="rect">
+            <a:avLst/>
+          </a:prstGeom>
+          <a:noFill/>
+          <a:ln/>
+        </p:spPr>
+        <p:txBody>
+          <a:bodyPr wrap="square" lIns="0" tIns="0" rIns="0" bIns="0" rtlCol="0" anchor="t"/>
+          <a:lstStyle/>
+          <a:p>
+            <a:pPr indent="0" marL="0">
+              <a:buNone/>
+            </a:pPr>
+            <a:r>
+              <a:rPr lang="en-US" sz="1200" dirty="0">
                 <a:solidFill>
                   <a:schemeClr val="bg1"/>
                 </a:solidFill>
               </a:rPr>
-              <a:t>CHI</a:t>
-            </a:r>
-            <a:endParaRPr lang="en-US" sz="1800" dirty="0"/>
-          </a:p>
-          <a:p>
-            <a:pPr indent="0" marL="0">
-              <a:buNone/>
-            </a:pPr>
-            <a:r>
-              <a:rPr lang="en-US" sz="1300" dirty="0">
-                <a:solidFill>
-                  <a:schemeClr val="bg1"/>
-                </a:solidFill>
-              </a:rPr>
-              <a:t>Il distributore ideale: esempi reali già attivi</a:t>
-            </a:r>
-            <a:endParaRPr lang="en-US" sz="1800" dirty="0"/>
-          </a:p>
-        </p:txBody>
-      </p:sp>
-      <p:sp>
-        <p:nvSpPr>
-          <p:cNvPr id="8" name="Shape 5"/>
+              <a:t>Il profilo del partner ideale, con esempi reali già attivi</a:t>
+            </a:r>
+            <a:endParaRPr lang="en-US" sz="1200" dirty="0"/>
+          </a:p>
+        </p:txBody>
+      </p:sp>
+      <p:sp>
+        <p:nvSpPr>
+          <p:cNvPr id="8" name="Spazio esempi"/>
           <p:cNvSpPr/>
           <p:nvPr/>
         </p:nvSpPr>
         <p:spPr>
           <a:xfrm>
-            <a:off x="4297680" y="3611880"/>
-            <a:ext cx="3520440" cy="1463040"/>
+            <a:off x="777240" y="4572000"/>
+            <a:ext cx="3063240" cy="1051560"/>
           </a:xfrm>
           <a:prstGeom prst="roundRect">
             <a:avLst>
-              <a:gd name="adj" fmla="val 7500"/>
+              <a:gd name="adj" fmla="val 6957"/>
+            </a:avLst>
+          </a:prstGeom>
+          <a:solidFill>
+            <a:schemeClr val="tx1"/>
+          </a:solidFill>
+          <a:ln w="12700">
+            <a:solidFill>
+              <a:schemeClr val="accent4"/>
+            </a:solidFill>
+            <a:prstDash val="dash"/>
+          </a:ln>
+        </p:spPr>
+      </p:sp>
+      <p:sp>
+        <p:nvSpPr>
+          <p:cNvPr id="9" name="Text 6"/>
+          <p:cNvSpPr txBox="1"/>
+          <p:nvPr/>
+        </p:nvSpPr>
+        <p:spPr>
+          <a:xfrm>
+            <a:off x="868680" y="4617720"/>
+            <a:ext cx="2834640" cy="228600"/>
+          </a:xfrm>
+          <a:prstGeom prst="rect">
+            <a:avLst/>
+          </a:prstGeom>
+          <a:noFill/>
+          <a:ln/>
+        </p:spPr>
+        <p:txBody>
+          <a:bodyPr wrap="square" lIns="0" tIns="0" rIns="0" bIns="0" rtlCol="0" anchor="ctr"/>
+          <a:lstStyle/>
+          <a:p>
+            <a:pPr indent="0" marL="0">
+              <a:buNone/>
+            </a:pPr>
+            <a:r>
+              <a:rPr lang="en-US" sz="1000" b="1" dirty="0">
+                <a:solidFill>
+                  <a:schemeClr val="accent4"/>
+                </a:solidFill>
+              </a:rPr>
+              <a:t>ESEMPI</a:t>
+            </a:r>
+            <a:endParaRPr lang="en-US" sz="1000" dirty="0"/>
+          </a:p>
+        </p:txBody>
+      </p:sp>
+      <p:sp>
+        <p:nvSpPr>
+          <p:cNvPr id="10" name="Shape 7"/>
+          <p:cNvSpPr/>
+          <p:nvPr/>
+        </p:nvSpPr>
+        <p:spPr>
+          <a:xfrm>
+            <a:off x="4297680" y="3017520"/>
+            <a:ext cx="3520440" cy="2788920"/>
+          </a:xfrm>
+          <a:prstGeom prst="roundRect">
+            <a:avLst>
+              <a:gd name="adj" fmla="val 3934"/>
             </a:avLst>
           </a:prstGeom>
           <a:solidFill>
@@ -9258,14 +9508,14 @@
       </p:sp>
       <p:sp>
         <p:nvSpPr>
-          <p:cNvPr id="9" name="Text 6"/>
-          <p:cNvSpPr txBox="1"/>
-          <p:nvPr/>
-        </p:nvSpPr>
-        <p:spPr>
-          <a:xfrm>
-            <a:off x="4526280" y="3703320"/>
-            <a:ext cx="731520" cy="1280160"/>
+          <p:cNvPr id="11" name="Text 8"/>
+          <p:cNvSpPr txBox="1"/>
+          <p:nvPr/>
+        </p:nvSpPr>
+        <p:spPr>
+          <a:xfrm>
+            <a:off x="4480560" y="3108960"/>
+            <a:ext cx="548640" cy="731520"/>
           </a:xfrm>
           <a:prstGeom prst="rect">
             <a:avLst/>
@@ -9281,27 +9531,27 @@
               <a:buNone/>
             </a:pPr>
             <a:r>
-              <a:rPr lang="en-US" sz="6000" b="1" dirty="0">
+              <a:rPr lang="en-US" sz="4400" b="1" dirty="0">
                 <a:solidFill>
                   <a:schemeClr val="accent1"/>
                 </a:solidFill>
               </a:rPr>
               <a:t>2</a:t>
             </a:r>
-            <a:endParaRPr lang="en-US" sz="6000" dirty="0"/>
-          </a:p>
-        </p:txBody>
-      </p:sp>
-      <p:sp>
-        <p:nvSpPr>
-          <p:cNvPr id="10" name="Text 7"/>
-          <p:cNvSpPr txBox="1"/>
-          <p:nvPr/>
-        </p:nvSpPr>
-        <p:spPr>
-          <a:xfrm>
-            <a:off x="5303520" y="3703320"/>
-            <a:ext cx="2377440" cy="1280160"/>
+            <a:endParaRPr lang="en-US" sz="4400" dirty="0"/>
+          </a:p>
+        </p:txBody>
+      </p:sp>
+      <p:sp>
+        <p:nvSpPr>
+          <p:cNvPr id="12" name="Text 9"/>
+          <p:cNvSpPr txBox="1"/>
+          <p:nvPr/>
+        </p:nvSpPr>
+        <p:spPr>
+          <a:xfrm>
+            <a:off x="5074920" y="3108960"/>
+            <a:ext cx="2606040" cy="731520"/>
           </a:xfrm>
           <a:prstGeom prst="rect">
             <a:avLst/>
@@ -9317,45 +9567,105 @@
               <a:buNone/>
             </a:pPr>
             <a:r>
-              <a:rPr lang="en-US" sz="1800" b="1" dirty="0">
+              <a:rPr lang="en-US" sz="1700" b="1" dirty="0">
                 <a:solidFill>
                   <a:schemeClr val="bg1"/>
                 </a:solidFill>
               </a:rPr>
-              <a:t>QUANTO</a:t>
-            </a:r>
-            <a:endParaRPr lang="en-US" sz="1800" dirty="0"/>
-          </a:p>
-          <a:p>
-            <a:pPr indent="0" marL="0">
-              <a:buNone/>
-            </a:pPr>
-            <a:r>
-              <a:rPr lang="en-US" sz="1300" dirty="0">
+              <a:t>Quanto fatturato può generare</a:t>
+            </a:r>
+            <a:endParaRPr lang="en-US" sz="1700" dirty="0"/>
+          </a:p>
+        </p:txBody>
+      </p:sp>
+      <p:sp>
+        <p:nvSpPr>
+          <p:cNvPr id="13" name="Text 10"/>
+          <p:cNvSpPr txBox="1"/>
+          <p:nvPr/>
+        </p:nvSpPr>
+        <p:spPr>
+          <a:xfrm>
+            <a:off x="4526280" y="3886200"/>
+            <a:ext cx="3063240" cy="640080"/>
+          </a:xfrm>
+          <a:prstGeom prst="rect">
+            <a:avLst/>
+          </a:prstGeom>
+          <a:noFill/>
+          <a:ln/>
+        </p:spPr>
+        <p:txBody>
+          <a:bodyPr wrap="square" lIns="0" tIns="0" rIns="0" bIns="0" rtlCol="0" anchor="t"/>
+          <a:lstStyle/>
+          <a:p>
+            <a:pPr indent="0" marL="0">
+              <a:buNone/>
+            </a:pPr>
+            <a:r>
+              <a:rPr lang="en-US" sz="1200" dirty="0">
                 <a:solidFill>
                   <a:schemeClr val="bg1"/>
                 </a:solidFill>
               </a:rPr>
-              <a:t>Fatturato misurato in altri mercati</a:t>
-            </a:r>
-            <a:endParaRPr lang="en-US" sz="1800" dirty="0"/>
-          </a:p>
-        </p:txBody>
-      </p:sp>
-      <p:sp>
-        <p:nvSpPr>
-          <p:cNvPr id="11" name="Shape 8"/>
+              <a:t>Risultati misurati sui partner già attivi in altri mercati</a:t>
+            </a:r>
+            <a:endParaRPr lang="en-US" sz="1200" dirty="0"/>
+          </a:p>
+        </p:txBody>
+      </p:sp>
+      <p:sp>
+        <p:nvSpPr>
+          <p:cNvPr id="14" name="Text 11"/>
+          <p:cNvSpPr txBox="1"/>
+          <p:nvPr/>
+        </p:nvSpPr>
+        <p:spPr>
+          <a:xfrm>
+            <a:off x="4526280" y="4663440"/>
+            <a:ext cx="3063240" cy="594360"/>
+          </a:xfrm>
+          <a:prstGeom prst="rect">
+            <a:avLst/>
+          </a:prstGeom>
+          <a:noFill/>
+          <a:ln/>
+        </p:spPr>
+        <p:txBody>
+          <a:bodyPr wrap="square" lIns="0" tIns="0" rIns="0" bIns="0" rtlCol="0" anchor="ctr">
+            <a:normAutofit/>
+          </a:bodyPr>
+          <a:lstStyle/>
+          <a:p>
+            <a:pPr indent="0" marL="0">
+              <a:buNone/>
+            </a:pPr>
+            <a:r>
+              <a:rPr lang="en-US" sz="2200" b="1" dirty="0">
+                <a:solidFill>
+                  <a:schemeClr val="accent1"/>
+                </a:solidFill>
+              </a:rPr>
+              <a:t>10.000 – 150.000+ €</a:t>
+            </a:r>
+            <a:endParaRPr lang="en-US" sz="2200" dirty="0"/>
+          </a:p>
+        </p:txBody>
+      </p:sp>
+      <p:sp>
+        <p:nvSpPr>
+          <p:cNvPr id="15" name="Shape 12"/>
           <p:cNvSpPr/>
           <p:nvPr/>
         </p:nvSpPr>
         <p:spPr>
           <a:xfrm>
-            <a:off x="8046720" y="3611880"/>
-            <a:ext cx="3520440" cy="1463040"/>
+            <a:off x="8046720" y="3017520"/>
+            <a:ext cx="3520440" cy="2788920"/>
           </a:xfrm>
           <a:prstGeom prst="roundRect">
             <a:avLst>
-              <a:gd name="adj" fmla="val 7500"/>
+              <a:gd name="adj" fmla="val 3934"/>
             </a:avLst>
           </a:prstGeom>
           <a:solidFill>
@@ -9371,14 +9681,14 @@
       </p:sp>
       <p:sp>
         <p:nvSpPr>
-          <p:cNvPr id="12" name="Text 9"/>
-          <p:cNvSpPr txBox="1"/>
-          <p:nvPr/>
-        </p:nvSpPr>
-        <p:spPr>
-          <a:xfrm>
-            <a:off x="8275320" y="3703320"/>
-            <a:ext cx="731520" cy="1280160"/>
+          <p:cNvPr id="16" name="Text 13"/>
+          <p:cNvSpPr txBox="1"/>
+          <p:nvPr/>
+        </p:nvSpPr>
+        <p:spPr>
+          <a:xfrm>
+            <a:off x="8229600" y="3108960"/>
+            <a:ext cx="548640" cy="731520"/>
           </a:xfrm>
           <a:prstGeom prst="rect">
             <a:avLst/>
@@ -9394,27 +9704,27 @@
               <a:buNone/>
             </a:pPr>
             <a:r>
-              <a:rPr lang="en-US" sz="6000" b="1" dirty="0">
+              <a:rPr lang="en-US" sz="4400" b="1" dirty="0">
                 <a:solidFill>
                   <a:schemeClr val="accent1"/>
                 </a:solidFill>
               </a:rPr>
               <a:t>3</a:t>
             </a:r>
-            <a:endParaRPr lang="en-US" sz="6000" dirty="0"/>
-          </a:p>
-        </p:txBody>
-      </p:sp>
-      <p:sp>
-        <p:nvSpPr>
-          <p:cNvPr id="13" name="Text 10"/>
-          <p:cNvSpPr txBox="1"/>
-          <p:nvPr/>
-        </p:nvSpPr>
-        <p:spPr>
-          <a:xfrm>
-            <a:off x="9052560" y="3703320"/>
-            <a:ext cx="2377440" cy="1280160"/>
+            <a:endParaRPr lang="en-US" sz="4400" dirty="0"/>
+          </a:p>
+        </p:txBody>
+      </p:sp>
+      <p:sp>
+        <p:nvSpPr>
+          <p:cNvPr id="17" name="Text 14"/>
+          <p:cNvSpPr txBox="1"/>
+          <p:nvPr/>
+        </p:nvSpPr>
+        <p:spPr>
+          <a:xfrm>
+            <a:off x="8823960" y="3108960"/>
+            <a:ext cx="2606040" cy="731520"/>
           </a:xfrm>
           <a:prstGeom prst="rect">
             <a:avLst/>
@@ -9430,41 +9740,101 @@
               <a:buNone/>
             </a:pPr>
             <a:r>
-              <a:rPr lang="en-US" sz="1800" b="1" dirty="0">
+              <a:rPr lang="en-US" sz="1700" b="1" dirty="0">
                 <a:solidFill>
                   <a:schemeClr val="bg1"/>
                 </a:solidFill>
               </a:rPr>
-              <a:t>DOVE</a:t>
-            </a:r>
-            <a:endParaRPr lang="en-US" sz="1800" dirty="0"/>
-          </a:p>
-          <a:p>
-            <a:pPr indent="0" marL="0">
-              <a:buNone/>
-            </a:pPr>
-            <a:r>
-              <a:rPr lang="en-US" sz="1300" dirty="0">
+              <a:t>Come individuarlo in Germania</a:t>
+            </a:r>
+            <a:endParaRPr lang="en-US" sz="1700" dirty="0"/>
+          </a:p>
+        </p:txBody>
+      </p:sp>
+      <p:sp>
+        <p:nvSpPr>
+          <p:cNvPr id="18" name="Text 15"/>
+          <p:cNvSpPr txBox="1"/>
+          <p:nvPr/>
+        </p:nvSpPr>
+        <p:spPr>
+          <a:xfrm>
+            <a:off x="8275320" y="3886200"/>
+            <a:ext cx="3063240" cy="640080"/>
+          </a:xfrm>
+          <a:prstGeom prst="rect">
+            <a:avLst/>
+          </a:prstGeom>
+          <a:noFill/>
+          <a:ln/>
+        </p:spPr>
+        <p:txBody>
+          <a:bodyPr wrap="square" lIns="0" tIns="0" rIns="0" bIns="0" rtlCol="0" anchor="t"/>
+          <a:lstStyle/>
+          <a:p>
+            <a:pPr indent="0" marL="0">
+              <a:buNone/>
+            </a:pPr>
+            <a:r>
+              <a:rPr lang="en-US" sz="1200" dirty="0">
                 <a:solidFill>
                   <a:schemeClr val="bg1"/>
                 </a:solidFill>
               </a:rPr>
-              <a:t>Mappatura mirata, canale per canale</a:t>
-            </a:r>
-            <a:endParaRPr lang="en-US" sz="1800" dirty="0"/>
-          </a:p>
-        </p:txBody>
-      </p:sp>
-      <p:sp>
-        <p:nvSpPr>
-          <p:cNvPr id="14" name="Text 11"/>
-          <p:cNvSpPr txBox="1"/>
-          <p:nvPr/>
-        </p:nvSpPr>
-        <p:spPr>
-          <a:xfrm>
-            <a:off x="548640" y="5440680"/>
-            <a:ext cx="10972800" cy="411480"/>
+              <a:t>Attraverso una mappatura mirata dei potenziali partner, canale per canale</a:t>
+            </a:r>
+            <a:endParaRPr lang="en-US" sz="1200" dirty="0"/>
+          </a:p>
+        </p:txBody>
+      </p:sp>
+      <p:sp>
+        <p:nvSpPr>
+          <p:cNvPr id="19" name="Text 16"/>
+          <p:cNvSpPr txBox="1"/>
+          <p:nvPr/>
+        </p:nvSpPr>
+        <p:spPr>
+          <a:xfrm>
+            <a:off x="8275320" y="4663440"/>
+            <a:ext cx="3063240" cy="594360"/>
+          </a:xfrm>
+          <a:prstGeom prst="rect">
+            <a:avLst/>
+          </a:prstGeom>
+          <a:noFill/>
+          <a:ln/>
+        </p:spPr>
+        <p:txBody>
+          <a:bodyPr wrap="square" lIns="0" tIns="0" rIns="0" bIns="0" rtlCol="0" anchor="ctr">
+            <a:normAutofit/>
+          </a:bodyPr>
+          <a:lstStyle/>
+          <a:p>
+            <a:pPr indent="0" marL="0">
+              <a:buNone/>
+            </a:pPr>
+            <a:r>
+              <a:rPr lang="en-US" sz="3400" b="1" dirty="0">
+                <a:solidFill>
+                  <a:schemeClr val="accent1"/>
+                </a:solidFill>
+              </a:rPr>
+              <a:t>6 canali</a:t>
+            </a:r>
+            <a:endParaRPr lang="en-US" sz="3400" dirty="0"/>
+          </a:p>
+        </p:txBody>
+      </p:sp>
+      <p:sp>
+        <p:nvSpPr>
+          <p:cNvPr id="20" name="Text 17"/>
+          <p:cNvSpPr txBox="1"/>
+          <p:nvPr/>
+        </p:nvSpPr>
+        <p:spPr>
+          <a:xfrm>
+            <a:off x="548640" y="5897880"/>
+            <a:ext cx="10972800" cy="365760"/>
           </a:xfrm>
           <a:prstGeom prst="rect">
             <a:avLst/>
@@ -9480,26 +9850,26 @@
               <a:buNone/>
             </a:pPr>
             <a:r>
-              <a:rPr lang="en-US" sz="1800" b="1" dirty="0">
+              <a:rPr lang="en-US" sz="1600" b="1" dirty="0">
                 <a:solidFill>
                   <a:schemeClr val="bg1"/>
                 </a:solidFill>
               </a:rPr>
               <a:t>Prossimo passo: un database di partner per canale, costruito insieme.</a:t>
             </a:r>
-            <a:endParaRPr lang="en-US" sz="1800" dirty="0"/>
-          </a:p>
-        </p:txBody>
-      </p:sp>
-      <p:sp>
-        <p:nvSpPr>
-          <p:cNvPr id="15" name="Text 12"/>
-          <p:cNvSpPr txBox="1"/>
-          <p:nvPr/>
-        </p:nvSpPr>
-        <p:spPr>
-          <a:xfrm>
-            <a:off x="548640" y="6217920"/>
+            <a:endParaRPr lang="en-US" sz="1600" dirty="0"/>
+          </a:p>
+        </p:txBody>
+      </p:sp>
+      <p:sp>
+        <p:nvSpPr>
+          <p:cNvPr id="21" name="Text 18"/>
+          <p:cNvSpPr txBox="1"/>
+          <p:nvPr/>
+        </p:nvSpPr>
+        <p:spPr>
+          <a:xfrm>
+            <a:off x="548640" y="6355080"/>
             <a:ext cx="10972800" cy="274320"/>
           </a:xfrm>
           <a:prstGeom prst="rect">
@@ -9516,14 +9886,14 @@
               <a:buNone/>
             </a:pPr>
             <a:r>
-              <a:rPr lang="en-US" sz="1200" dirty="0">
+              <a:rPr lang="en-US" sz="1100" dirty="0">
                 <a:solidFill>
                   <a:schemeClr val="accent4"/>
                 </a:solidFill>
               </a:rPr>
               <a:t>DUPUY · Via Enrico de Nicola 27 · 10036 Settimo Torinese (TO) · Tel. +39 011 8975444 · info@dupuy.it</a:t>
             </a:r>
-            <a:endParaRPr lang="en-US" sz="1200" dirty="0"/>
+            <a:endParaRPr lang="en-US" sz="1100" dirty="0"/>
           </a:p>
         </p:txBody>
       </p:sp>

</xml_diff>